<commit_message>
Retotal 2027 marketing budget to $679,750
Co-Authored-By: Claude Opus 5.5 <noreply@anthropic.com>
Claude-Session: https://claude.ai/code/session_015KGeERGX8tZXyoMsdSGKK4
</commit_message>
<xml_diff>
--- a/2027_Marketing_Plan.pptx
+++ b/2027_Marketing_Plan.pptx
@@ -5,13 +5,13 @@
     <p:sldMasterId id="2147483648" r:id="rId1"/>
   </p:sldMasterIdLst>
   <p:sldIdLst>
-    <p:sldId id="256" r:id="rId7"/>
-    <p:sldId id="257" r:id="rId8"/>
-    <p:sldId id="258" r:id="rId9"/>
-    <p:sldId id="259" r:id="rId10"/>
-    <p:sldId id="260" r:id="rId11"/>
+    <p:sldId id="256" r:id="rId2"/>
+    <p:sldId id="257" r:id="rId3"/>
+    <p:sldId id="258" r:id="rId4"/>
+    <p:sldId id="259" r:id="rId5"/>
+    <p:sldId id="260" r:id="rId6"/>
   </p:sldIdLst>
-  <p:sldSz cx="12191695" cy="6858000" type="screen4x3"/>
+  <p:sldSz cx="12192000" cy="6858000"/>
   <p:notesSz cx="6858000" cy="9144000"/>
   <p:defaultTextStyle>
     <a:defPPr>
@@ -108,6 +108,22 @@
       </a:defRPr>
     </a:lvl9pPr>
   </p:defaultTextStyle>
+  <p:extLst>
+    <p:ext uri="{EFAFB233-063F-42B5-8137-9DF3F51BA10A}">
+      <p15:sldGuideLst xmlns:p15="http://schemas.microsoft.com/office/powerpoint/2012/main">
+        <p15:guide id="1" orient="horz" pos="2160">
+          <p15:clr>
+            <a:srgbClr val="A4A3A4"/>
+          </p15:clr>
+        </p15:guide>
+        <p15:guide id="2" pos="2880">
+          <p15:clr>
+            <a:srgbClr val="A4A3A4"/>
+          </p15:clr>
+        </p15:guide>
+      </p15:sldGuideLst>
+    </p:ext>
+  </p:extLst>
 </p:presentation>
 </file>
 
@@ -149,10 +165,9 @@
           <a:lstStyle/>
           <a:p>
             <a:r>
-              <a:rPr lang="en-US" smtClean="0"/>
+              <a:rPr lang="en-US"/>
               <a:t>Click to edit Master title style</a:t>
             </a:r>
-            <a:endParaRPr lang="en-US"/>
           </a:p>
         </p:txBody>
       </p:sp>
@@ -268,10 +283,9 @@
           </a:lstStyle>
           <a:p>
             <a:r>
-              <a:rPr lang="en-US" smtClean="0"/>
+              <a:rPr lang="en-US"/>
               <a:t>Click to edit Master subtitle style</a:t>
             </a:r>
-            <a:endParaRPr lang="en-US"/>
           </a:p>
         </p:txBody>
       </p:sp>
@@ -292,7 +306,7 @@
           <a:p>
             <a:fld id="{5BCAD085-E8A6-8845-BD4E-CB4CCA059FC4}" type="datetimeFigureOut">
               <a:rPr lang="en-US" smtClean="0"/>
-              <a:t>1/27/13</a:t>
+              <a:t>10/25/26</a:t>
             </a:fld>
             <a:endParaRPr lang="en-US"/>
           </a:p>
@@ -386,10 +400,9 @@
           <a:lstStyle/>
           <a:p>
             <a:r>
-              <a:rPr lang="en-US" smtClean="0"/>
+              <a:rPr lang="en-US"/>
               <a:t>Click to edit Master title style</a:t>
             </a:r>
-            <a:endParaRPr lang="en-US"/>
           </a:p>
         </p:txBody>
       </p:sp>
@@ -410,38 +423,37 @@
           <a:p>
             <a:pPr lvl="0"/>
             <a:r>
-              <a:rPr lang="en-US" smtClean="0"/>
+              <a:rPr lang="en-US"/>
               <a:t>Click to edit Master text styles</a:t>
             </a:r>
           </a:p>
           <a:p>
             <a:pPr lvl="1"/>
             <a:r>
-              <a:rPr lang="en-US" smtClean="0"/>
+              <a:rPr lang="en-US"/>
               <a:t>Second level</a:t>
             </a:r>
           </a:p>
           <a:p>
             <a:pPr lvl="2"/>
             <a:r>
-              <a:rPr lang="en-US" smtClean="0"/>
+              <a:rPr lang="en-US"/>
               <a:t>Third level</a:t>
             </a:r>
           </a:p>
           <a:p>
             <a:pPr lvl="3"/>
             <a:r>
-              <a:rPr lang="en-US" smtClean="0"/>
+              <a:rPr lang="en-US"/>
               <a:t>Fourth level</a:t>
             </a:r>
           </a:p>
           <a:p>
             <a:pPr lvl="4"/>
             <a:r>
-              <a:rPr lang="en-US" smtClean="0"/>
+              <a:rPr lang="en-US"/>
               <a:t>Fifth level</a:t>
             </a:r>
-            <a:endParaRPr lang="en-US"/>
           </a:p>
         </p:txBody>
       </p:sp>
@@ -462,7 +474,7 @@
           <a:p>
             <a:fld id="{5BCAD085-E8A6-8845-BD4E-CB4CCA059FC4}" type="datetimeFigureOut">
               <a:rPr lang="en-US" smtClean="0"/>
-              <a:t>1/27/13</a:t>
+              <a:t>10/25/26</a:t>
             </a:fld>
             <a:endParaRPr lang="en-US"/>
           </a:p>
@@ -561,10 +573,9 @@
           <a:lstStyle/>
           <a:p>
             <a:r>
-              <a:rPr lang="en-US" smtClean="0"/>
+              <a:rPr lang="en-US"/>
               <a:t>Click to edit Master title style</a:t>
             </a:r>
-            <a:endParaRPr lang="en-US"/>
           </a:p>
         </p:txBody>
       </p:sp>
@@ -590,38 +601,37 @@
           <a:p>
             <a:pPr lvl="0"/>
             <a:r>
-              <a:rPr lang="en-US" smtClean="0"/>
+              <a:rPr lang="en-US"/>
               <a:t>Click to edit Master text styles</a:t>
             </a:r>
           </a:p>
           <a:p>
             <a:pPr lvl="1"/>
             <a:r>
-              <a:rPr lang="en-US" smtClean="0"/>
+              <a:rPr lang="en-US"/>
               <a:t>Second level</a:t>
             </a:r>
           </a:p>
           <a:p>
             <a:pPr lvl="2"/>
             <a:r>
-              <a:rPr lang="en-US" smtClean="0"/>
+              <a:rPr lang="en-US"/>
               <a:t>Third level</a:t>
             </a:r>
           </a:p>
           <a:p>
             <a:pPr lvl="3"/>
             <a:r>
-              <a:rPr lang="en-US" smtClean="0"/>
+              <a:rPr lang="en-US"/>
               <a:t>Fourth level</a:t>
             </a:r>
           </a:p>
           <a:p>
             <a:pPr lvl="4"/>
             <a:r>
-              <a:rPr lang="en-US" smtClean="0"/>
+              <a:rPr lang="en-US"/>
               <a:t>Fifth level</a:t>
             </a:r>
-            <a:endParaRPr lang="en-US"/>
           </a:p>
         </p:txBody>
       </p:sp>
@@ -642,7 +652,7 @@
           <a:p>
             <a:fld id="{5BCAD085-E8A6-8845-BD4E-CB4CCA059FC4}" type="datetimeFigureOut">
               <a:rPr lang="en-US" smtClean="0"/>
-              <a:t>1/27/13</a:t>
+              <a:t>10/25/26</a:t>
             </a:fld>
             <a:endParaRPr lang="en-US"/>
           </a:p>
@@ -736,10 +746,9 @@
           <a:lstStyle/>
           <a:p>
             <a:r>
-              <a:rPr lang="en-US" smtClean="0"/>
+              <a:rPr lang="en-US"/>
               <a:t>Click to edit Master title style</a:t>
             </a:r>
-            <a:endParaRPr lang="en-US"/>
           </a:p>
         </p:txBody>
       </p:sp>
@@ -760,38 +769,37 @@
           <a:p>
             <a:pPr lvl="0"/>
             <a:r>
-              <a:rPr lang="en-US" smtClean="0"/>
+              <a:rPr lang="en-US"/>
               <a:t>Click to edit Master text styles</a:t>
             </a:r>
           </a:p>
           <a:p>
             <a:pPr lvl="1"/>
             <a:r>
-              <a:rPr lang="en-US" smtClean="0"/>
+              <a:rPr lang="en-US"/>
               <a:t>Second level</a:t>
             </a:r>
           </a:p>
           <a:p>
             <a:pPr lvl="2"/>
             <a:r>
-              <a:rPr lang="en-US" smtClean="0"/>
+              <a:rPr lang="en-US"/>
               <a:t>Third level</a:t>
             </a:r>
           </a:p>
           <a:p>
             <a:pPr lvl="3"/>
             <a:r>
-              <a:rPr lang="en-US" smtClean="0"/>
+              <a:rPr lang="en-US"/>
               <a:t>Fourth level</a:t>
             </a:r>
           </a:p>
           <a:p>
             <a:pPr lvl="4"/>
             <a:r>
-              <a:rPr lang="en-US" smtClean="0"/>
+              <a:rPr lang="en-US"/>
               <a:t>Fifth level</a:t>
             </a:r>
-            <a:endParaRPr lang="en-US"/>
           </a:p>
         </p:txBody>
       </p:sp>
@@ -812,7 +820,7 @@
           <a:p>
             <a:fld id="{5BCAD085-E8A6-8845-BD4E-CB4CCA059FC4}" type="datetimeFigureOut">
               <a:rPr lang="en-US" smtClean="0"/>
-              <a:t>1/27/13</a:t>
+              <a:t>10/25/26</a:t>
             </a:fld>
             <a:endParaRPr lang="en-US"/>
           </a:p>
@@ -915,10 +923,9 @@
           </a:lstStyle>
           <a:p>
             <a:r>
-              <a:rPr lang="en-US" smtClean="0"/>
+              <a:rPr lang="en-US"/>
               <a:t>Click to edit Master title style</a:t>
             </a:r>
-            <a:endParaRPr lang="en-US"/>
           </a:p>
         </p:txBody>
       </p:sp>
@@ -1035,7 +1042,7 @@
           <a:p>
             <a:pPr lvl="0"/>
             <a:r>
-              <a:rPr lang="en-US" smtClean="0"/>
+              <a:rPr lang="en-US"/>
               <a:t>Click to edit Master text styles</a:t>
             </a:r>
           </a:p>
@@ -1058,7 +1065,7 @@
           <a:p>
             <a:fld id="{5BCAD085-E8A6-8845-BD4E-CB4CCA059FC4}" type="datetimeFigureOut">
               <a:rPr lang="en-US" smtClean="0"/>
-              <a:t>1/27/13</a:t>
+              <a:t>10/25/26</a:t>
             </a:fld>
             <a:endParaRPr lang="en-US"/>
           </a:p>
@@ -1152,10 +1159,9 @@
           <a:lstStyle/>
           <a:p>
             <a:r>
-              <a:rPr lang="en-US" smtClean="0"/>
+              <a:rPr lang="en-US"/>
               <a:t>Click to edit Master title style</a:t>
             </a:r>
-            <a:endParaRPr lang="en-US"/>
           </a:p>
         </p:txBody>
       </p:sp>
@@ -1209,38 +1215,37 @@
           <a:p>
             <a:pPr lvl="0"/>
             <a:r>
-              <a:rPr lang="en-US" smtClean="0"/>
+              <a:rPr lang="en-US"/>
               <a:t>Click to edit Master text styles</a:t>
             </a:r>
           </a:p>
           <a:p>
             <a:pPr lvl="1"/>
             <a:r>
-              <a:rPr lang="en-US" smtClean="0"/>
+              <a:rPr lang="en-US"/>
               <a:t>Second level</a:t>
             </a:r>
           </a:p>
           <a:p>
             <a:pPr lvl="2"/>
             <a:r>
-              <a:rPr lang="en-US" smtClean="0"/>
+              <a:rPr lang="en-US"/>
               <a:t>Third level</a:t>
             </a:r>
           </a:p>
           <a:p>
             <a:pPr lvl="3"/>
             <a:r>
-              <a:rPr lang="en-US" smtClean="0"/>
+              <a:rPr lang="en-US"/>
               <a:t>Fourth level</a:t>
             </a:r>
           </a:p>
           <a:p>
             <a:pPr lvl="4"/>
             <a:r>
-              <a:rPr lang="en-US" smtClean="0"/>
+              <a:rPr lang="en-US"/>
               <a:t>Fifth level</a:t>
             </a:r>
-            <a:endParaRPr lang="en-US"/>
           </a:p>
         </p:txBody>
       </p:sp>
@@ -1294,38 +1299,37 @@
           <a:p>
             <a:pPr lvl="0"/>
             <a:r>
-              <a:rPr lang="en-US" smtClean="0"/>
+              <a:rPr lang="en-US"/>
               <a:t>Click to edit Master text styles</a:t>
             </a:r>
           </a:p>
           <a:p>
             <a:pPr lvl="1"/>
             <a:r>
-              <a:rPr lang="en-US" smtClean="0"/>
+              <a:rPr lang="en-US"/>
               <a:t>Second level</a:t>
             </a:r>
           </a:p>
           <a:p>
             <a:pPr lvl="2"/>
             <a:r>
-              <a:rPr lang="en-US" smtClean="0"/>
+              <a:rPr lang="en-US"/>
               <a:t>Third level</a:t>
             </a:r>
           </a:p>
           <a:p>
             <a:pPr lvl="3"/>
             <a:r>
-              <a:rPr lang="en-US" smtClean="0"/>
+              <a:rPr lang="en-US"/>
               <a:t>Fourth level</a:t>
             </a:r>
           </a:p>
           <a:p>
             <a:pPr lvl="4"/>
             <a:r>
-              <a:rPr lang="en-US" smtClean="0"/>
+              <a:rPr lang="en-US"/>
               <a:t>Fifth level</a:t>
             </a:r>
-            <a:endParaRPr lang="en-US"/>
           </a:p>
         </p:txBody>
       </p:sp>
@@ -1346,7 +1350,7 @@
           <a:p>
             <a:fld id="{5BCAD085-E8A6-8845-BD4E-CB4CCA059FC4}" type="datetimeFigureOut">
               <a:rPr lang="en-US" smtClean="0"/>
-              <a:t>1/27/13</a:t>
+              <a:t>10/25/26</a:t>
             </a:fld>
             <a:endParaRPr lang="en-US"/>
           </a:p>
@@ -1444,10 +1448,9 @@
           </a:lstStyle>
           <a:p>
             <a:r>
-              <a:rPr lang="en-US" smtClean="0"/>
+              <a:rPr lang="en-US"/>
               <a:t>Click to edit Master title style</a:t>
             </a:r>
-            <a:endParaRPr lang="en-US"/>
           </a:p>
         </p:txBody>
       </p:sp>
@@ -1510,7 +1513,7 @@
           <a:p>
             <a:pPr lvl="0"/>
             <a:r>
-              <a:rPr lang="en-US" smtClean="0"/>
+              <a:rPr lang="en-US"/>
               <a:t>Click to edit Master text styles</a:t>
             </a:r>
           </a:p>
@@ -1566,38 +1569,37 @@
           <a:p>
             <a:pPr lvl="0"/>
             <a:r>
-              <a:rPr lang="en-US" smtClean="0"/>
+              <a:rPr lang="en-US"/>
               <a:t>Click to edit Master text styles</a:t>
             </a:r>
           </a:p>
           <a:p>
             <a:pPr lvl="1"/>
             <a:r>
-              <a:rPr lang="en-US" smtClean="0"/>
+              <a:rPr lang="en-US"/>
               <a:t>Second level</a:t>
             </a:r>
           </a:p>
           <a:p>
             <a:pPr lvl="2"/>
             <a:r>
-              <a:rPr lang="en-US" smtClean="0"/>
+              <a:rPr lang="en-US"/>
               <a:t>Third level</a:t>
             </a:r>
           </a:p>
           <a:p>
             <a:pPr lvl="3"/>
             <a:r>
-              <a:rPr lang="en-US" smtClean="0"/>
+              <a:rPr lang="en-US"/>
               <a:t>Fourth level</a:t>
             </a:r>
           </a:p>
           <a:p>
             <a:pPr lvl="4"/>
             <a:r>
-              <a:rPr lang="en-US" smtClean="0"/>
+              <a:rPr lang="en-US"/>
               <a:t>Fifth level</a:t>
             </a:r>
-            <a:endParaRPr lang="en-US"/>
           </a:p>
         </p:txBody>
       </p:sp>
@@ -1660,7 +1662,7 @@
           <a:p>
             <a:pPr lvl="0"/>
             <a:r>
-              <a:rPr lang="en-US" smtClean="0"/>
+              <a:rPr lang="en-US"/>
               <a:t>Click to edit Master text styles</a:t>
             </a:r>
           </a:p>
@@ -1716,38 +1718,37 @@
           <a:p>
             <a:pPr lvl="0"/>
             <a:r>
-              <a:rPr lang="en-US" smtClean="0"/>
+              <a:rPr lang="en-US"/>
               <a:t>Click to edit Master text styles</a:t>
             </a:r>
           </a:p>
           <a:p>
             <a:pPr lvl="1"/>
             <a:r>
-              <a:rPr lang="en-US" smtClean="0"/>
+              <a:rPr lang="en-US"/>
               <a:t>Second level</a:t>
             </a:r>
           </a:p>
           <a:p>
             <a:pPr lvl="2"/>
             <a:r>
-              <a:rPr lang="en-US" smtClean="0"/>
+              <a:rPr lang="en-US"/>
               <a:t>Third level</a:t>
             </a:r>
           </a:p>
           <a:p>
             <a:pPr lvl="3"/>
             <a:r>
-              <a:rPr lang="en-US" smtClean="0"/>
+              <a:rPr lang="en-US"/>
               <a:t>Fourth level</a:t>
             </a:r>
           </a:p>
           <a:p>
             <a:pPr lvl="4"/>
             <a:r>
-              <a:rPr lang="en-US" smtClean="0"/>
+              <a:rPr lang="en-US"/>
               <a:t>Fifth level</a:t>
             </a:r>
-            <a:endParaRPr lang="en-US"/>
           </a:p>
         </p:txBody>
       </p:sp>
@@ -1768,7 +1769,7 @@
           <a:p>
             <a:fld id="{5BCAD085-E8A6-8845-BD4E-CB4CCA059FC4}" type="datetimeFigureOut">
               <a:rPr lang="en-US" smtClean="0"/>
-              <a:t>1/27/13</a:t>
+              <a:t>10/25/26</a:t>
             </a:fld>
             <a:endParaRPr lang="en-US"/>
           </a:p>
@@ -1862,10 +1863,9 @@
           <a:lstStyle/>
           <a:p>
             <a:r>
-              <a:rPr lang="en-US" smtClean="0"/>
+              <a:rPr lang="en-US"/>
               <a:t>Click to edit Master title style</a:t>
             </a:r>
-            <a:endParaRPr lang="en-US"/>
           </a:p>
         </p:txBody>
       </p:sp>
@@ -1886,7 +1886,7 @@
           <a:p>
             <a:fld id="{5BCAD085-E8A6-8845-BD4E-CB4CCA059FC4}" type="datetimeFigureOut">
               <a:rPr lang="en-US" smtClean="0"/>
-              <a:t>1/27/13</a:t>
+              <a:t>10/25/26</a:t>
             </a:fld>
             <a:endParaRPr lang="en-US"/>
           </a:p>
@@ -1981,7 +1981,7 @@
           <a:p>
             <a:fld id="{5BCAD085-E8A6-8845-BD4E-CB4CCA059FC4}" type="datetimeFigureOut">
               <a:rPr lang="en-US" smtClean="0"/>
-              <a:t>1/27/13</a:t>
+              <a:t>10/25/26</a:t>
             </a:fld>
             <a:endParaRPr lang="en-US"/>
           </a:p>
@@ -2084,10 +2084,9 @@
           </a:lstStyle>
           <a:p>
             <a:r>
-              <a:rPr lang="en-US" smtClean="0"/>
+              <a:rPr lang="en-US"/>
               <a:t>Click to edit Master title style</a:t>
             </a:r>
-            <a:endParaRPr lang="en-US"/>
           </a:p>
         </p:txBody>
       </p:sp>
@@ -2141,38 +2140,37 @@
           <a:p>
             <a:pPr lvl="0"/>
             <a:r>
-              <a:rPr lang="en-US" smtClean="0"/>
+              <a:rPr lang="en-US"/>
               <a:t>Click to edit Master text styles</a:t>
             </a:r>
           </a:p>
           <a:p>
             <a:pPr lvl="1"/>
             <a:r>
-              <a:rPr lang="en-US" smtClean="0"/>
+              <a:rPr lang="en-US"/>
               <a:t>Second level</a:t>
             </a:r>
           </a:p>
           <a:p>
             <a:pPr lvl="2"/>
             <a:r>
-              <a:rPr lang="en-US" smtClean="0"/>
+              <a:rPr lang="en-US"/>
               <a:t>Third level</a:t>
             </a:r>
           </a:p>
           <a:p>
             <a:pPr lvl="3"/>
             <a:r>
-              <a:rPr lang="en-US" smtClean="0"/>
+              <a:rPr lang="en-US"/>
               <a:t>Fourth level</a:t>
             </a:r>
           </a:p>
           <a:p>
             <a:pPr lvl="4"/>
             <a:r>
-              <a:rPr lang="en-US" smtClean="0"/>
+              <a:rPr lang="en-US"/>
               <a:t>Fifth level</a:t>
             </a:r>
-            <a:endParaRPr lang="en-US"/>
           </a:p>
         </p:txBody>
       </p:sp>
@@ -2235,7 +2233,7 @@
           <a:p>
             <a:pPr lvl="0"/>
             <a:r>
-              <a:rPr lang="en-US" smtClean="0"/>
+              <a:rPr lang="en-US"/>
               <a:t>Click to edit Master text styles</a:t>
             </a:r>
           </a:p>
@@ -2258,7 +2256,7 @@
           <a:p>
             <a:fld id="{5BCAD085-E8A6-8845-BD4E-CB4CCA059FC4}" type="datetimeFigureOut">
               <a:rPr lang="en-US" smtClean="0"/>
-              <a:t>1/27/13</a:t>
+              <a:t>10/25/26</a:t>
             </a:fld>
             <a:endParaRPr lang="en-US"/>
           </a:p>
@@ -2361,10 +2359,9 @@
           </a:lstStyle>
           <a:p>
             <a:r>
-              <a:rPr lang="en-US" smtClean="0"/>
+              <a:rPr lang="en-US"/>
               <a:t>Click to edit Master title style</a:t>
             </a:r>
-            <a:endParaRPr lang="en-US"/>
           </a:p>
         </p:txBody>
       </p:sp>
@@ -2488,7 +2485,7 @@
           <a:p>
             <a:pPr lvl="0"/>
             <a:r>
-              <a:rPr lang="en-US" smtClean="0"/>
+              <a:rPr lang="en-US"/>
               <a:t>Click to edit Master text styles</a:t>
             </a:r>
           </a:p>
@@ -2511,7 +2508,7 @@
           <a:p>
             <a:fld id="{5BCAD085-E8A6-8845-BD4E-CB4CCA059FC4}" type="datetimeFigureOut">
               <a:rPr lang="en-US" smtClean="0"/>
-              <a:t>1/27/13</a:t>
+              <a:t>10/25/26</a:t>
             </a:fld>
             <a:endParaRPr lang="en-US"/>
           </a:p>
@@ -2620,10 +2617,9 @@
           <a:lstStyle/>
           <a:p>
             <a:r>
-              <a:rPr lang="en-US" smtClean="0"/>
+              <a:rPr lang="en-US"/>
               <a:t>Click to edit Master title style</a:t>
             </a:r>
-            <a:endParaRPr lang="en-US"/>
           </a:p>
         </p:txBody>
       </p:sp>
@@ -2654,38 +2650,37 @@
           <a:p>
             <a:pPr lvl="0"/>
             <a:r>
-              <a:rPr lang="en-US" smtClean="0"/>
+              <a:rPr lang="en-US"/>
               <a:t>Click to edit Master text styles</a:t>
             </a:r>
           </a:p>
           <a:p>
             <a:pPr lvl="1"/>
             <a:r>
-              <a:rPr lang="en-US" smtClean="0"/>
+              <a:rPr lang="en-US"/>
               <a:t>Second level</a:t>
             </a:r>
           </a:p>
           <a:p>
             <a:pPr lvl="2"/>
             <a:r>
-              <a:rPr lang="en-US" smtClean="0"/>
+              <a:rPr lang="en-US"/>
               <a:t>Third level</a:t>
             </a:r>
           </a:p>
           <a:p>
             <a:pPr lvl="3"/>
             <a:r>
-              <a:rPr lang="en-US" smtClean="0"/>
+              <a:rPr lang="en-US"/>
               <a:t>Fourth level</a:t>
             </a:r>
           </a:p>
           <a:p>
             <a:pPr lvl="4"/>
             <a:r>
-              <a:rPr lang="en-US" smtClean="0"/>
+              <a:rPr lang="en-US"/>
               <a:t>Fifth level</a:t>
             </a:r>
-            <a:endParaRPr lang="en-US"/>
           </a:p>
         </p:txBody>
       </p:sp>
@@ -2724,7 +2719,7 @@
           <a:p>
             <a:fld id="{5BCAD085-E8A6-8845-BD4E-CB4CCA059FC4}" type="datetimeFigureOut">
               <a:rPr lang="en-US" smtClean="0"/>
-              <a:t>1/27/13</a:t>
+              <a:t>10/25/26</a:t>
             </a:fld>
             <a:endParaRPr lang="en-US"/>
           </a:p>
@@ -3083,7 +3078,7 @@
 </file>
 
 <file path=ppt/slides/slide1.xml><?xml version="1.0" encoding="utf-8"?>
-<p:sld xmlns:a="http://schemas.openxmlformats.org/drawingml/2006/main" xmlns:p="http://schemas.openxmlformats.org/presentationml/2006/main" xmlns:r="http://schemas.openxmlformats.org/officeDocument/2006/relationships">
+<p:sld xmlns:a="http://schemas.openxmlformats.org/drawingml/2006/main" xmlns:r="http://schemas.openxmlformats.org/officeDocument/2006/relationships" xmlns:p="http://schemas.openxmlformats.org/presentationml/2006/main">
   <p:cSld>
     <p:bg>
       <p:bgPr>
@@ -3099,7 +3094,14 @@
         <p:cNvGrpSpPr/>
         <p:nvPr/>
       </p:nvGrpSpPr>
-      <p:grpSpPr/>
+      <p:grpSpPr>
+        <a:xfrm>
+          <a:off x="0" y="0"/>
+          <a:ext cx="0" cy="0"/>
+          <a:chOff x="0" y="0"/>
+          <a:chExt cx="0" cy="0"/>
+        </a:xfrm>
+      </p:grpSpPr>
       <p:sp>
         <p:nvSpPr>
           <p:cNvPr id="2" name="Eyebrow"/>
@@ -3117,7 +3119,7 @@
           <a:noFill/>
         </p:spPr>
         <p:txBody>
-          <a:bodyPr wrap="square" anchor="t" lIns="0" rIns="0" tIns="0" bIns="0">
+          <a:bodyPr wrap="square" lIns="0" tIns="0" rIns="0" bIns="0" anchor="t">
             <a:spAutoFit/>
           </a:bodyPr>
           <a:lstStyle/>
@@ -3152,7 +3154,7 @@
           <a:noFill/>
         </p:spPr>
         <p:txBody>
-          <a:bodyPr wrap="square" anchor="t" lIns="0" rIns="0" tIns="0" bIns="0">
+          <a:bodyPr wrap="square" lIns="0" tIns="0" rIns="0" bIns="0" anchor="t">
             <a:spAutoFit/>
           </a:bodyPr>
           <a:lstStyle/>
@@ -3187,7 +3189,7 @@
           <a:noFill/>
         </p:spPr>
         <p:txBody>
-          <a:bodyPr wrap="square" anchor="t" lIns="0" rIns="0" tIns="0" bIns="0">
+          <a:bodyPr wrap="square" lIns="0" tIns="0" rIns="0" bIns="0" anchor="t">
             <a:spAutoFit/>
           </a:bodyPr>
           <a:lstStyle/>
@@ -3214,7 +3216,7 @@
 </file>
 
 <file path=ppt/slides/slide2.xml><?xml version="1.0" encoding="utf-8"?>
-<p:sld xmlns:a="http://schemas.openxmlformats.org/drawingml/2006/main" xmlns:p="http://schemas.openxmlformats.org/presentationml/2006/main" xmlns:r="http://schemas.openxmlformats.org/officeDocument/2006/relationships">
+<p:sld xmlns:a="http://schemas.openxmlformats.org/drawingml/2006/main" xmlns:r="http://schemas.openxmlformats.org/officeDocument/2006/relationships" xmlns:p="http://schemas.openxmlformats.org/presentationml/2006/main">
   <p:cSld>
     <p:bg>
       <p:bgPr>
@@ -3230,7 +3232,14 @@
         <p:cNvGrpSpPr/>
         <p:nvPr/>
       </p:nvGrpSpPr>
-      <p:grpSpPr/>
+      <p:grpSpPr>
+        <a:xfrm>
+          <a:off x="0" y="0"/>
+          <a:ext cx="0" cy="0"/>
+          <a:chOff x="0" y="0"/>
+          <a:chExt cx="0" cy="0"/>
+        </a:xfrm>
+      </p:grpSpPr>
       <p:sp>
         <p:nvSpPr>
           <p:cNvPr id="2" name="Title"/>
@@ -3248,7 +3257,7 @@
           <a:noFill/>
         </p:spPr>
         <p:txBody>
-          <a:bodyPr wrap="square" anchor="t" lIns="0" rIns="0" tIns="0" bIns="0">
+          <a:bodyPr wrap="square" lIns="0" tIns="0" rIns="0" bIns="0" anchor="t">
             <a:spAutoFit/>
           </a:bodyPr>
           <a:lstStyle/>
@@ -3283,7 +3292,7 @@
           <a:noFill/>
         </p:spPr>
         <p:txBody>
-          <a:bodyPr wrap="square" anchor="t" lIns="0" rIns="0" tIns="0" bIns="0">
+          <a:bodyPr wrap="square" lIns="0" tIns="0" rIns="0" bIns="0" anchor="t">
             <a:spAutoFit/>
           </a:bodyPr>
           <a:lstStyle/>
@@ -3318,7 +3327,7 @@
           <a:noFill/>
         </p:spPr>
         <p:txBody>
-          <a:bodyPr wrap="square" anchor="t" lIns="0" rIns="0" tIns="0" bIns="0">
+          <a:bodyPr wrap="square" lIns="0" tIns="0" rIns="0" bIns="0" anchor="t">
             <a:spAutoFit/>
           </a:bodyPr>
           <a:lstStyle/>
@@ -3353,7 +3362,7 @@
           <a:noFill/>
         </p:spPr>
         <p:txBody>
-          <a:bodyPr wrap="square" anchor="t" lIns="0" rIns="0" tIns="0" bIns="0">
+          <a:bodyPr wrap="square" lIns="0" tIns="0" rIns="0" bIns="0" anchor="t">
             <a:spAutoFit/>
           </a:bodyPr>
           <a:lstStyle/>
@@ -3416,6 +3425,7 @@
           <a:lstStyle/>
           <a:p>
             <a:pPr algn="ctr"/>
+            <a:endParaRPr/>
           </a:p>
         </p:txBody>
       </p:sp>
@@ -3456,7 +3466,7 @@
           </a:fontRef>
         </p:style>
         <p:txBody>
-          <a:bodyPr rtlCol="0" anchor="ctr" lIns="0" rIns="0" tIns="0" bIns="0"/>
+          <a:bodyPr lIns="0" tIns="0" rIns="0" bIns="0" rtlCol="0" anchor="ctr"/>
           <a:lstStyle/>
           <a:p>
             <a:pPr algn="ctr"/>
@@ -3489,7 +3499,7 @@
           <a:noFill/>
         </p:spPr>
         <p:txBody>
-          <a:bodyPr wrap="square" anchor="t" lIns="0" rIns="0" tIns="0" bIns="0">
+          <a:bodyPr wrap="square" lIns="0" tIns="0" rIns="0" bIns="0" anchor="t">
             <a:spAutoFit/>
           </a:bodyPr>
           <a:lstStyle/>
@@ -3552,6 +3562,7 @@
           <a:lstStyle/>
           <a:p>
             <a:pPr algn="ctr"/>
+            <a:endParaRPr/>
           </a:p>
         </p:txBody>
       </p:sp>
@@ -3592,7 +3603,7 @@
           </a:fontRef>
         </p:style>
         <p:txBody>
-          <a:bodyPr rtlCol="0" anchor="ctr" lIns="0" rIns="0" tIns="0" bIns="0"/>
+          <a:bodyPr lIns="0" tIns="0" rIns="0" bIns="0" rtlCol="0" anchor="ctr"/>
           <a:lstStyle/>
           <a:p>
             <a:pPr algn="ctr"/>
@@ -3625,7 +3636,7 @@
           <a:noFill/>
         </p:spPr>
         <p:txBody>
-          <a:bodyPr wrap="square" anchor="t" lIns="0" rIns="0" tIns="0" bIns="0">
+          <a:bodyPr wrap="square" lIns="0" tIns="0" rIns="0" bIns="0" anchor="t">
             <a:spAutoFit/>
           </a:bodyPr>
           <a:lstStyle/>
@@ -3688,6 +3699,7 @@
           <a:lstStyle/>
           <a:p>
             <a:pPr algn="ctr"/>
+            <a:endParaRPr/>
           </a:p>
         </p:txBody>
       </p:sp>
@@ -3728,7 +3740,7 @@
           </a:fontRef>
         </p:style>
         <p:txBody>
-          <a:bodyPr rtlCol="0" anchor="ctr" lIns="0" rIns="0" tIns="0" bIns="0"/>
+          <a:bodyPr lIns="0" tIns="0" rIns="0" bIns="0" rtlCol="0" anchor="ctr"/>
           <a:lstStyle/>
           <a:p>
             <a:pPr algn="ctr"/>
@@ -3761,7 +3773,7 @@
           <a:noFill/>
         </p:spPr>
         <p:txBody>
-          <a:bodyPr wrap="square" anchor="t" lIns="0" rIns="0" tIns="0" bIns="0">
+          <a:bodyPr wrap="square" lIns="0" tIns="0" rIns="0" bIns="0" anchor="t">
             <a:spAutoFit/>
           </a:bodyPr>
           <a:lstStyle/>
@@ -3824,6 +3836,7 @@
           <a:lstStyle/>
           <a:p>
             <a:pPr algn="ctr"/>
+            <a:endParaRPr/>
           </a:p>
         </p:txBody>
       </p:sp>
@@ -3864,7 +3877,7 @@
           </a:fontRef>
         </p:style>
         <p:txBody>
-          <a:bodyPr rtlCol="0" anchor="ctr" lIns="0" rIns="0" tIns="0" bIns="0"/>
+          <a:bodyPr lIns="0" tIns="0" rIns="0" bIns="0" rtlCol="0" anchor="ctr"/>
           <a:lstStyle/>
           <a:p>
             <a:pPr algn="ctr"/>
@@ -3897,7 +3910,7 @@
           <a:noFill/>
         </p:spPr>
         <p:txBody>
-          <a:bodyPr wrap="square" anchor="t" lIns="0" rIns="0" tIns="0" bIns="0">
+          <a:bodyPr wrap="square" lIns="0" tIns="0" rIns="0" bIns="0" anchor="t">
             <a:spAutoFit/>
           </a:bodyPr>
           <a:lstStyle/>
@@ -3924,7 +3937,7 @@
 </file>
 
 <file path=ppt/slides/slide3.xml><?xml version="1.0" encoding="utf-8"?>
-<p:sld xmlns:a="http://schemas.openxmlformats.org/drawingml/2006/main" xmlns:p="http://schemas.openxmlformats.org/presentationml/2006/main" xmlns:r="http://schemas.openxmlformats.org/officeDocument/2006/relationships">
+<p:sld xmlns:a="http://schemas.openxmlformats.org/drawingml/2006/main" xmlns:r="http://schemas.openxmlformats.org/officeDocument/2006/relationships" xmlns:p="http://schemas.openxmlformats.org/presentationml/2006/main">
   <p:cSld>
     <p:bg>
       <p:bgPr>
@@ -3940,7 +3953,14 @@
         <p:cNvGrpSpPr/>
         <p:nvPr/>
       </p:nvGrpSpPr>
-      <p:grpSpPr/>
+      <p:grpSpPr>
+        <a:xfrm>
+          <a:off x="0" y="0"/>
+          <a:ext cx="0" cy="0"/>
+          <a:chOff x="0" y="0"/>
+          <a:chExt cx="0" cy="0"/>
+        </a:xfrm>
+      </p:grpSpPr>
       <p:sp>
         <p:nvSpPr>
           <p:cNvPr id="2" name="Title"/>
@@ -3958,7 +3978,7 @@
           <a:noFill/>
         </p:spPr>
         <p:txBody>
-          <a:bodyPr wrap="square" anchor="t" lIns="0" rIns="0" tIns="0" bIns="0">
+          <a:bodyPr wrap="square" lIns="0" tIns="0" rIns="0" bIns="0" anchor="t">
             <a:spAutoFit/>
           </a:bodyPr>
           <a:lstStyle/>
@@ -3993,7 +4013,7 @@
           <a:noFill/>
         </p:spPr>
         <p:txBody>
-          <a:bodyPr wrap="square" anchor="t" lIns="0" rIns="0" tIns="0" bIns="0">
+          <a:bodyPr wrap="square" lIns="0" tIns="0" rIns="0" bIns="0" anchor="t">
             <a:spAutoFit/>
           </a:bodyPr>
           <a:lstStyle/>
@@ -4028,7 +4048,7 @@
           <a:noFill/>
         </p:spPr>
         <p:txBody>
-          <a:bodyPr wrap="square" anchor="t" lIns="0" rIns="0" tIns="0" bIns="0">
+          <a:bodyPr wrap="square" lIns="0" tIns="0" rIns="0" bIns="0" anchor="t">
             <a:spAutoFit/>
           </a:bodyPr>
           <a:lstStyle/>
@@ -4091,6 +4111,7 @@
           <a:lstStyle/>
           <a:p>
             <a:pPr algn="ctr"/>
+            <a:endParaRPr/>
           </a:p>
         </p:txBody>
       </p:sp>
@@ -4131,7 +4152,7 @@
           </a:fontRef>
         </p:style>
         <p:txBody>
-          <a:bodyPr rtlCol="0" anchor="ctr" lIns="0" rIns="0" tIns="0" bIns="0"/>
+          <a:bodyPr lIns="0" tIns="0" rIns="0" bIns="0" rtlCol="0" anchor="ctr"/>
           <a:lstStyle/>
           <a:p>
             <a:pPr algn="ctr"/>
@@ -4164,7 +4185,7 @@
           <a:noFill/>
         </p:spPr>
         <p:txBody>
-          <a:bodyPr wrap="square" anchor="t" lIns="0" rIns="0" tIns="0" bIns="0">
+          <a:bodyPr wrap="square" lIns="0" tIns="0" rIns="0" bIns="0" anchor="t">
             <a:spAutoFit/>
           </a:bodyPr>
           <a:lstStyle/>
@@ -4227,6 +4248,7 @@
           <a:lstStyle/>
           <a:p>
             <a:pPr algn="ctr"/>
+            <a:endParaRPr/>
           </a:p>
         </p:txBody>
       </p:sp>
@@ -4267,7 +4289,7 @@
           </a:fontRef>
         </p:style>
         <p:txBody>
-          <a:bodyPr rtlCol="0" anchor="ctr" lIns="0" rIns="0" tIns="0" bIns="0"/>
+          <a:bodyPr lIns="0" tIns="0" rIns="0" bIns="0" rtlCol="0" anchor="ctr"/>
           <a:lstStyle/>
           <a:p>
             <a:pPr algn="ctr"/>
@@ -4300,7 +4322,7 @@
           <a:noFill/>
         </p:spPr>
         <p:txBody>
-          <a:bodyPr wrap="square" anchor="t" lIns="0" rIns="0" tIns="0" bIns="0">
+          <a:bodyPr wrap="square" lIns="0" tIns="0" rIns="0" bIns="0" anchor="t">
             <a:spAutoFit/>
           </a:bodyPr>
           <a:lstStyle/>
@@ -4363,6 +4385,7 @@
           <a:lstStyle/>
           <a:p>
             <a:pPr algn="ctr"/>
+            <a:endParaRPr/>
           </a:p>
         </p:txBody>
       </p:sp>
@@ -4403,7 +4426,7 @@
           </a:fontRef>
         </p:style>
         <p:txBody>
-          <a:bodyPr rtlCol="0" anchor="ctr" lIns="0" rIns="0" tIns="0" bIns="0"/>
+          <a:bodyPr lIns="0" tIns="0" rIns="0" bIns="0" rtlCol="0" anchor="ctr"/>
           <a:lstStyle/>
           <a:p>
             <a:pPr algn="ctr"/>
@@ -4436,7 +4459,7 @@
           <a:noFill/>
         </p:spPr>
         <p:txBody>
-          <a:bodyPr wrap="square" anchor="t" lIns="0" rIns="0" tIns="0" bIns="0">
+          <a:bodyPr wrap="square" lIns="0" tIns="0" rIns="0" bIns="0" anchor="t">
             <a:spAutoFit/>
           </a:bodyPr>
           <a:lstStyle/>
@@ -4499,6 +4522,7 @@
           <a:lstStyle/>
           <a:p>
             <a:pPr algn="ctr"/>
+            <a:endParaRPr/>
           </a:p>
         </p:txBody>
       </p:sp>
@@ -4539,7 +4563,7 @@
           </a:fontRef>
         </p:style>
         <p:txBody>
-          <a:bodyPr rtlCol="0" anchor="ctr" lIns="0" rIns="0" tIns="0" bIns="0"/>
+          <a:bodyPr lIns="0" tIns="0" rIns="0" bIns="0" rtlCol="0" anchor="ctr"/>
           <a:lstStyle/>
           <a:p>
             <a:pPr algn="ctr"/>
@@ -4572,7 +4596,7 @@
           <a:noFill/>
         </p:spPr>
         <p:txBody>
-          <a:bodyPr wrap="square" anchor="t" lIns="0" rIns="0" tIns="0" bIns="0">
+          <a:bodyPr wrap="square" lIns="0" tIns="0" rIns="0" bIns="0" anchor="t">
             <a:spAutoFit/>
           </a:bodyPr>
           <a:lstStyle/>
@@ -4599,7 +4623,7 @@
 </file>
 
 <file path=ppt/slides/slide4.xml><?xml version="1.0" encoding="utf-8"?>
-<p:sld xmlns:a="http://schemas.openxmlformats.org/drawingml/2006/main" xmlns:p="http://schemas.openxmlformats.org/presentationml/2006/main" xmlns:r="http://schemas.openxmlformats.org/officeDocument/2006/relationships">
+<p:sld xmlns:a="http://schemas.openxmlformats.org/drawingml/2006/main" xmlns:r="http://schemas.openxmlformats.org/officeDocument/2006/relationships" xmlns:p="http://schemas.openxmlformats.org/presentationml/2006/main">
   <p:cSld>
     <p:bg>
       <p:bgPr>
@@ -4615,7 +4639,14 @@
         <p:cNvGrpSpPr/>
         <p:nvPr/>
       </p:nvGrpSpPr>
-      <p:grpSpPr/>
+      <p:grpSpPr>
+        <a:xfrm>
+          <a:off x="0" y="0"/>
+          <a:ext cx="0" cy="0"/>
+          <a:chOff x="0" y="0"/>
+          <a:chExt cx="0" cy="0"/>
+        </a:xfrm>
+      </p:grpSpPr>
       <p:sp>
         <p:nvSpPr>
           <p:cNvPr id="2" name="Title"/>
@@ -4633,7 +4664,7 @@
           <a:noFill/>
         </p:spPr>
         <p:txBody>
-          <a:bodyPr wrap="square" anchor="t" lIns="0" rIns="0" tIns="0" bIns="0">
+          <a:bodyPr wrap="square" lIns="0" tIns="0" rIns="0" bIns="0" anchor="t">
             <a:spAutoFit/>
           </a:bodyPr>
           <a:lstStyle/>
@@ -4668,7 +4699,7 @@
           <a:noFill/>
         </p:spPr>
         <p:txBody>
-          <a:bodyPr wrap="square" anchor="t" lIns="0" rIns="0" tIns="0" bIns="0">
+          <a:bodyPr wrap="square" lIns="0" tIns="0" rIns="0" bIns="0" anchor="t">
             <a:spAutoFit/>
           </a:bodyPr>
           <a:lstStyle/>
@@ -4703,7 +4734,7 @@
           <a:noFill/>
         </p:spPr>
         <p:txBody>
-          <a:bodyPr wrap="square" anchor="t" lIns="0" rIns="0" tIns="0" bIns="0">
+          <a:bodyPr wrap="square" lIns="0" tIns="0" rIns="0" bIns="0" anchor="t">
             <a:spAutoFit/>
           </a:bodyPr>
           <a:lstStyle/>
@@ -4766,6 +4797,7 @@
           <a:lstStyle/>
           <a:p>
             <a:pPr algn="ctr"/>
+            <a:endParaRPr/>
           </a:p>
         </p:txBody>
       </p:sp>
@@ -4806,7 +4838,7 @@
           </a:fontRef>
         </p:style>
         <p:txBody>
-          <a:bodyPr rtlCol="0" anchor="ctr" lIns="0" rIns="0" tIns="0" bIns="0"/>
+          <a:bodyPr lIns="0" tIns="0" rIns="0" bIns="0" rtlCol="0" anchor="ctr"/>
           <a:lstStyle/>
           <a:p>
             <a:pPr algn="ctr"/>
@@ -4839,7 +4871,7 @@
           <a:noFill/>
         </p:spPr>
         <p:txBody>
-          <a:bodyPr wrap="square" anchor="t" lIns="0" rIns="0" tIns="0" bIns="0">
+          <a:bodyPr wrap="square" lIns="0" tIns="0" rIns="0" bIns="0" anchor="t">
             <a:spAutoFit/>
           </a:bodyPr>
           <a:lstStyle/>
@@ -4902,6 +4934,7 @@
           <a:lstStyle/>
           <a:p>
             <a:pPr algn="ctr"/>
+            <a:endParaRPr/>
           </a:p>
         </p:txBody>
       </p:sp>
@@ -4942,7 +4975,7 @@
           </a:fontRef>
         </p:style>
         <p:txBody>
-          <a:bodyPr rtlCol="0" anchor="ctr" lIns="0" rIns="0" tIns="0" bIns="0"/>
+          <a:bodyPr lIns="0" tIns="0" rIns="0" bIns="0" rtlCol="0" anchor="ctr"/>
           <a:lstStyle/>
           <a:p>
             <a:pPr algn="ctr"/>
@@ -4975,7 +5008,7 @@
           <a:noFill/>
         </p:spPr>
         <p:txBody>
-          <a:bodyPr wrap="square" anchor="t" lIns="0" rIns="0" tIns="0" bIns="0">
+          <a:bodyPr wrap="square" lIns="0" tIns="0" rIns="0" bIns="0" anchor="t">
             <a:spAutoFit/>
           </a:bodyPr>
           <a:lstStyle/>
@@ -5010,7 +5043,7 @@
           <a:noFill/>
         </p:spPr>
         <p:txBody>
-          <a:bodyPr wrap="square" anchor="t" lIns="0" rIns="0" tIns="0" bIns="0">
+          <a:bodyPr wrap="square" lIns="0" tIns="0" rIns="0" bIns="0" anchor="t">
             <a:spAutoFit/>
           </a:bodyPr>
           <a:lstStyle/>
@@ -5093,6 +5126,7 @@
           <a:lstStyle/>
           <a:p>
             <a:pPr algn="ctr"/>
+            <a:endParaRPr/>
           </a:p>
         </p:txBody>
       </p:sp>
@@ -5133,7 +5167,7 @@
           </a:fontRef>
         </p:style>
         <p:txBody>
-          <a:bodyPr rtlCol="0" anchor="ctr" lIns="0" rIns="0" tIns="0" bIns="0"/>
+          <a:bodyPr lIns="0" tIns="0" rIns="0" bIns="0" rtlCol="0" anchor="ctr"/>
           <a:lstStyle/>
           <a:p>
             <a:pPr algn="ctr"/>
@@ -5166,7 +5200,7 @@
           <a:noFill/>
         </p:spPr>
         <p:txBody>
-          <a:bodyPr wrap="square" anchor="t" lIns="0" rIns="0" tIns="0" bIns="0">
+          <a:bodyPr wrap="square" lIns="0" tIns="0" rIns="0" bIns="0" anchor="t">
             <a:spAutoFit/>
           </a:bodyPr>
           <a:lstStyle/>
@@ -5193,7 +5227,7 @@
 </file>
 
 <file path=ppt/slides/slide5.xml><?xml version="1.0" encoding="utf-8"?>
-<p:sld xmlns:a="http://schemas.openxmlformats.org/drawingml/2006/main" xmlns:p="http://schemas.openxmlformats.org/presentationml/2006/main" xmlns:r="http://schemas.openxmlformats.org/officeDocument/2006/relationships">
+<p:sld xmlns:a="http://schemas.openxmlformats.org/drawingml/2006/main" xmlns:r="http://schemas.openxmlformats.org/officeDocument/2006/relationships" xmlns:p="http://schemas.openxmlformats.org/presentationml/2006/main">
   <p:cSld>
     <p:bg>
       <p:bgPr>
@@ -5209,7 +5243,14 @@
         <p:cNvGrpSpPr/>
         <p:nvPr/>
       </p:nvGrpSpPr>
-      <p:grpSpPr/>
+      <p:grpSpPr>
+        <a:xfrm>
+          <a:off x="0" y="0"/>
+          <a:ext cx="0" cy="0"/>
+          <a:chOff x="0" y="0"/>
+          <a:chExt cx="0" cy="0"/>
+        </a:xfrm>
+      </p:grpSpPr>
       <p:sp>
         <p:nvSpPr>
           <p:cNvPr id="2" name="Title"/>
@@ -5227,7 +5268,7 @@
           <a:noFill/>
         </p:spPr>
         <p:txBody>
-          <a:bodyPr wrap="square" anchor="t" lIns="0" rIns="0" tIns="0" bIns="0">
+          <a:bodyPr wrap="square" lIns="0" tIns="0" rIns="0" bIns="0" anchor="t">
             <a:spAutoFit/>
           </a:bodyPr>
           <a:lstStyle/>
@@ -5240,21 +5281,21 @@
                 </a:solidFill>
                 <a:latin typeface="Arial"/>
               </a:rPr>
-              <a:t>Marketing Budget: $613,750</a:t>
-            </a:r>
-          </a:p>
-        </p:txBody>
-      </p:sp>
-      <p:sp>
-        <p:nvSpPr>
-          <p:cNvPr id="3" name="Footer"/>
+              <a:t>Marketing Budget: $679,750</a:t>
+            </a:r>
+          </a:p>
+        </p:txBody>
+      </p:sp>
+      <p:sp>
+        <p:nvSpPr>
+          <p:cNvPr id="4" name="Page number"/>
           <p:cNvSpPr txBox="1"/>
           <p:nvPr/>
         </p:nvSpPr>
         <p:spPr>
           <a:xfrm>
-            <a:off x="548640" y="6355080"/>
-            <a:ext cx="10180015" cy="274320"/>
+            <a:off x="11094415" y="6355080"/>
+            <a:ext cx="548640" cy="274320"/>
           </a:xfrm>
           <a:prstGeom prst="rect">
             <a:avLst/>
@@ -5262,42 +5303,7 @@
           <a:noFill/>
         </p:spPr>
         <p:txBody>
-          <a:bodyPr wrap="square" anchor="t" lIns="0" rIns="0" tIns="0" bIns="0">
-            <a:spAutoFit/>
-          </a:bodyPr>
-          <a:lstStyle/>
-          <a:p>
-            <a:pPr algn="l"/>
-            <a:r>
-              <a:rPr sz="1000" b="0">
-                <a:solidFill>
-                  <a:srgbClr val="5A6478"/>
-                </a:solidFill>
-                <a:latin typeface="Arial"/>
-              </a:rPr>
-              <a:t>Coastal Air Plus · 2027 Marketing Plan</a:t>
-            </a:r>
-          </a:p>
-        </p:txBody>
-      </p:sp>
-      <p:sp>
-        <p:nvSpPr>
-          <p:cNvPr id="4" name="Page number"/>
-          <p:cNvSpPr txBox="1"/>
-          <p:nvPr/>
-        </p:nvSpPr>
-        <p:spPr>
-          <a:xfrm>
-            <a:off x="11094415" y="6355080"/>
-            <a:ext cx="548640" cy="274320"/>
-          </a:xfrm>
-          <a:prstGeom prst="rect">
-            <a:avLst/>
-          </a:prstGeom>
-          <a:noFill/>
-        </p:spPr>
-        <p:txBody>
-          <a:bodyPr wrap="square" anchor="t" lIns="0" rIns="0" tIns="0" bIns="0">
+          <a:bodyPr wrap="square" lIns="0" tIns="0" rIns="0" bIns="0" anchor="t">
             <a:spAutoFit/>
           </a:bodyPr>
           <a:lstStyle/>
@@ -5321,7 +5327,13 @@
           <p:cNvGraphicFramePr>
             <a:graphicFrameLocks noGrp="1"/>
           </p:cNvGraphicFramePr>
-          <p:nvPr/>
+          <p:nvPr>
+            <p:extLst>
+              <p:ext uri="{D42A27DB-BD31-4B8C-83A1-F6EECF244321}">
+                <p14:modId xmlns:p14="http://schemas.microsoft.com/office/powerpoint/2010/main" val="816310501"/>
+              </p:ext>
+            </p:extLst>
+          </p:nvPr>
         </p:nvGraphicFramePr>
         <p:xfrm>
           <a:off x="548640" y="1234440"/>
@@ -5334,9 +5346,27 @@
                 <a:tableStyleId>{5C22544A-7EE6-4342-B048-85BDC9FD1C3A}</a:tableStyleId>
               </a:tblPr>
               <a:tblGrid>
-                <a:gridCol w="3840480"/>
-                <a:gridCol w="1645920"/>
-                <a:gridCol w="1280160"/>
+                <a:gridCol w="3840480">
+                  <a:extLst>
+                    <a:ext uri="{9D8B030D-6E8A-4147-A177-3AD203B41FA5}">
+                      <a16:colId xmlns:a16="http://schemas.microsoft.com/office/drawing/2014/main" val="20000"/>
+                    </a:ext>
+                  </a:extLst>
+                </a:gridCol>
+                <a:gridCol w="1645920">
+                  <a:extLst>
+                    <a:ext uri="{9D8B030D-6E8A-4147-A177-3AD203B41FA5}">
+                      <a16:colId xmlns:a16="http://schemas.microsoft.com/office/drawing/2014/main" val="20001"/>
+                    </a:ext>
+                  </a:extLst>
+                </a:gridCol>
+                <a:gridCol w="1280160">
+                  <a:extLst>
+                    <a:ext uri="{9D8B030D-6E8A-4147-A177-3AD203B41FA5}">
+                      <a16:colId xmlns:a16="http://schemas.microsoft.com/office/drawing/2014/main" val="20002"/>
+                    </a:ext>
+                  </a:extLst>
+                </a:gridCol>
               </a:tblGrid>
               <a:tr h="329184">
                 <a:tc>
@@ -5356,7 +5386,7 @@
                       </a:r>
                     </a:p>
                   </a:txBody>
-                  <a:tcPr marL="91440" marR="91440" marT="18288" marB="18288" anchor="ctr">
+                  <a:tcPr marT="18288" marB="18288" anchor="ctr">
                     <a:solidFill>
                       <a:srgbClr val="14213D"/>
                     </a:solidFill>
@@ -5379,7 +5409,7 @@
                       </a:r>
                     </a:p>
                   </a:txBody>
-                  <a:tcPr marL="91440" marR="91440" marT="18288" marB="18288" anchor="ctr">
+                  <a:tcPr marT="18288" marB="18288" anchor="ctr">
                     <a:solidFill>
                       <a:srgbClr val="14213D"/>
                     </a:solidFill>
@@ -5402,12 +5432,17 @@
                       </a:r>
                     </a:p>
                   </a:txBody>
-                  <a:tcPr marL="91440" marR="91440" marT="18288" marB="18288" anchor="ctr">
+                  <a:tcPr marT="18288" marB="18288" anchor="ctr">
                     <a:solidFill>
                       <a:srgbClr val="14213D"/>
                     </a:solidFill>
                   </a:tcPr>
                 </a:tc>
+                <a:extLst>
+                  <a:ext uri="{0D108BD9-81ED-4DB2-BD59-A6C34878D82A}">
+                    <a16:rowId xmlns:a16="http://schemas.microsoft.com/office/drawing/2014/main" val="10000"/>
+                  </a:ext>
+                </a:extLst>
               </a:tr>
               <a:tr h="329184">
                 <a:tc>
@@ -5427,7 +5462,45 @@
                       </a:r>
                     </a:p>
                   </a:txBody>
-                  <a:tcPr marL="91440" marR="91440" marT="18288" marB="18288" anchor="ctr">
+                  <a:tcPr marT="18288" marB="18288" anchor="ctr">
+                    <a:solidFill>
+                      <a:srgbClr val="FFFFFF"/>
+                    </a:solidFill>
+                  </a:tcPr>
+                </a:tc>
+                <a:tc>
+                  <a:txBody>
+                    <a:bodyPr/>
+                    <a:lstStyle/>
+                    <a:p>
+                      <a:pPr algn="r"/>
+                      <a:r>
+                        <a:rPr sz="1300" b="0" dirty="0">
+                          <a:solidFill>
+                            <a:srgbClr val="14213D"/>
+                          </a:solidFill>
+                          <a:latin typeface="Arial"/>
+                        </a:rPr>
+                        <a:t>$4</a:t>
+                      </a:r>
+                      <a:r>
+                        <a:rPr lang="en-US" sz="1300" b="0" dirty="0">
+                          <a:solidFill>
+                            <a:srgbClr val="14213D"/>
+                          </a:solidFill>
+                          <a:latin typeface="Arial"/>
+                        </a:rPr>
+                        <a:t>86,000</a:t>
+                      </a:r>
+                      <a:endParaRPr sz="1300" b="0" dirty="0">
+                        <a:solidFill>
+                          <a:srgbClr val="14213D"/>
+                        </a:solidFill>
+                        <a:latin typeface="Arial"/>
+                      </a:endParaRPr>
+                    </a:p>
+                  </a:txBody>
+                  <a:tcPr marT="18288" marB="18288" anchor="ctr">
                     <a:solidFill>
                       <a:srgbClr val="FFFFFF"/>
                     </a:solidFill>
@@ -5446,39 +5519,21 @@
                           </a:solidFill>
                           <a:latin typeface="Arial"/>
                         </a:rPr>
-                        <a:t>$420,000</a:t>
+                        <a:t>71.5%</a:t>
                       </a:r>
                     </a:p>
                   </a:txBody>
-                  <a:tcPr marL="91440" marR="91440" marT="18288" marB="18288" anchor="ctr">
+                  <a:tcPr marT="18288" marB="18288" anchor="ctr">
                     <a:solidFill>
                       <a:srgbClr val="FFFFFF"/>
                     </a:solidFill>
                   </a:tcPr>
                 </a:tc>
-                <a:tc>
-                  <a:txBody>
-                    <a:bodyPr/>
-                    <a:lstStyle/>
-                    <a:p>
-                      <a:pPr algn="r"/>
-                      <a:r>
-                        <a:rPr sz="1300" b="0">
-                          <a:solidFill>
-                            <a:srgbClr val="14213D"/>
-                          </a:solidFill>
-                          <a:latin typeface="Arial"/>
-                        </a:rPr>
-                        <a:t>68.4%</a:t>
-                      </a:r>
-                    </a:p>
-                  </a:txBody>
-                  <a:tcPr marL="91440" marR="91440" marT="18288" marB="18288" anchor="ctr">
-                    <a:solidFill>
-                      <a:srgbClr val="FFFFFF"/>
-                    </a:solidFill>
-                  </a:tcPr>
-                </a:tc>
+                <a:extLst>
+                  <a:ext uri="{0D108BD9-81ED-4DB2-BD59-A6C34878D82A}">
+                    <a16:rowId xmlns:a16="http://schemas.microsoft.com/office/drawing/2014/main" val="10001"/>
+                  </a:ext>
+                </a:extLst>
               </a:tr>
               <a:tr h="329184">
                 <a:tc>
@@ -5498,7 +5553,7 @@
                       </a:r>
                     </a:p>
                   </a:txBody>
-                  <a:tcPr marL="91440" marR="91440" marT="18288" marB="18288" anchor="ctr">
+                  <a:tcPr marT="18288" marB="18288" anchor="ctr">
                     <a:solidFill>
                       <a:srgbClr val="F7F6F2"/>
                     </a:solidFill>
@@ -5521,7 +5576,7 @@
                       </a:r>
                     </a:p>
                   </a:txBody>
-                  <a:tcPr marL="91440" marR="91440" marT="18288" marB="18288" anchor="ctr">
+                  <a:tcPr marT="18288" marB="18288" anchor="ctr">
                     <a:solidFill>
                       <a:srgbClr val="F7F6F2"/>
                     </a:solidFill>
@@ -5540,16 +5595,21 @@
                           </a:solidFill>
                           <a:latin typeface="Arial"/>
                         </a:rPr>
-                        <a:t>4.9%</a:t>
+                        <a:t>4.4%</a:t>
                       </a:r>
                     </a:p>
                   </a:txBody>
-                  <a:tcPr marL="91440" marR="91440" marT="18288" marB="18288" anchor="ctr">
+                  <a:tcPr marT="18288" marB="18288" anchor="ctr">
                     <a:solidFill>
                       <a:srgbClr val="F7F6F2"/>
                     </a:solidFill>
                   </a:tcPr>
                 </a:tc>
+                <a:extLst>
+                  <a:ext uri="{0D108BD9-81ED-4DB2-BD59-A6C34878D82A}">
+                    <a16:rowId xmlns:a16="http://schemas.microsoft.com/office/drawing/2014/main" val="10002"/>
+                  </a:ext>
+                </a:extLst>
               </a:tr>
               <a:tr h="329184">
                 <a:tc>
@@ -5569,7 +5629,7 @@
                       </a:r>
                     </a:p>
                   </a:txBody>
-                  <a:tcPr marL="91440" marR="91440" marT="18288" marB="18288" anchor="ctr">
+                  <a:tcPr marT="18288" marB="18288" anchor="ctr">
                     <a:solidFill>
                       <a:srgbClr val="FFFFFF"/>
                     </a:solidFill>
@@ -5592,7 +5652,7 @@
                       </a:r>
                     </a:p>
                   </a:txBody>
-                  <a:tcPr marL="91440" marR="91440" marT="18288" marB="18288" anchor="ctr">
+                  <a:tcPr marT="18288" marB="18288" anchor="ctr">
                     <a:solidFill>
                       <a:srgbClr val="FFFFFF"/>
                     </a:solidFill>
@@ -5611,16 +5671,21 @@
                           </a:solidFill>
                           <a:latin typeface="Arial"/>
                         </a:rPr>
-                        <a:t>4.9%</a:t>
+                        <a:t>4.4%</a:t>
                       </a:r>
                     </a:p>
                   </a:txBody>
-                  <a:tcPr marL="91440" marR="91440" marT="18288" marB="18288" anchor="ctr">
+                  <a:tcPr marT="18288" marB="18288" anchor="ctr">
                     <a:solidFill>
                       <a:srgbClr val="FFFFFF"/>
                     </a:solidFill>
                   </a:tcPr>
                 </a:tc>
+                <a:extLst>
+                  <a:ext uri="{0D108BD9-81ED-4DB2-BD59-A6C34878D82A}">
+                    <a16:rowId xmlns:a16="http://schemas.microsoft.com/office/drawing/2014/main" val="10003"/>
+                  </a:ext>
+                </a:extLst>
               </a:tr>
               <a:tr h="329184">
                 <a:tc>
@@ -5640,7 +5705,7 @@
                       </a:r>
                     </a:p>
                   </a:txBody>
-                  <a:tcPr marL="91440" marR="91440" marT="18288" marB="18288" anchor="ctr">
+                  <a:tcPr marT="18288" marB="18288" anchor="ctr">
                     <a:solidFill>
                       <a:srgbClr val="F7F6F2"/>
                     </a:solidFill>
@@ -5663,7 +5728,7 @@
                       </a:r>
                     </a:p>
                   </a:txBody>
-                  <a:tcPr marL="91440" marR="91440" marT="18288" marB="18288" anchor="ctr">
+                  <a:tcPr marT="18288" marB="18288" anchor="ctr">
                     <a:solidFill>
                       <a:srgbClr val="F7F6F2"/>
                     </a:solidFill>
@@ -5682,16 +5747,21 @@
                           </a:solidFill>
                           <a:latin typeface="Arial"/>
                         </a:rPr>
-                        <a:t>12.2%</a:t>
+                        <a:t>11.0%</a:t>
                       </a:r>
                     </a:p>
                   </a:txBody>
-                  <a:tcPr marL="91440" marR="91440" marT="18288" marB="18288" anchor="ctr">
+                  <a:tcPr marT="18288" marB="18288" anchor="ctr">
                     <a:solidFill>
                       <a:srgbClr val="F7F6F2"/>
                     </a:solidFill>
                   </a:tcPr>
                 </a:tc>
+                <a:extLst>
+                  <a:ext uri="{0D108BD9-81ED-4DB2-BD59-A6C34878D82A}">
+                    <a16:rowId xmlns:a16="http://schemas.microsoft.com/office/drawing/2014/main" val="10004"/>
+                  </a:ext>
+                </a:extLst>
               </a:tr>
               <a:tr h="329184">
                 <a:tc>
@@ -5711,7 +5781,7 @@
                       </a:r>
                     </a:p>
                   </a:txBody>
-                  <a:tcPr marL="91440" marR="91440" marT="18288" marB="18288" anchor="ctr">
+                  <a:tcPr marT="18288" marB="18288" anchor="ctr">
                     <a:solidFill>
                       <a:srgbClr val="FFFFFF"/>
                     </a:solidFill>
@@ -5734,7 +5804,7 @@
                       </a:r>
                     </a:p>
                   </a:txBody>
-                  <a:tcPr marL="91440" marR="91440" marT="18288" marB="18288" anchor="ctr">
+                  <a:tcPr marT="18288" marB="18288" anchor="ctr">
                     <a:solidFill>
                       <a:srgbClr val="FFFFFF"/>
                     </a:solidFill>
@@ -5753,16 +5823,21 @@
                           </a:solidFill>
                           <a:latin typeface="Arial"/>
                         </a:rPr>
-                        <a:t>0.5%</a:t>
+                        <a:t>0.4%</a:t>
                       </a:r>
                     </a:p>
                   </a:txBody>
-                  <a:tcPr marL="91440" marR="91440" marT="18288" marB="18288" anchor="ctr">
+                  <a:tcPr marT="18288" marB="18288" anchor="ctr">
                     <a:solidFill>
                       <a:srgbClr val="FFFFFF"/>
                     </a:solidFill>
                   </a:tcPr>
                 </a:tc>
+                <a:extLst>
+                  <a:ext uri="{0D108BD9-81ED-4DB2-BD59-A6C34878D82A}">
+                    <a16:rowId xmlns:a16="http://schemas.microsoft.com/office/drawing/2014/main" val="10005"/>
+                  </a:ext>
+                </a:extLst>
               </a:tr>
               <a:tr h="329184">
                 <a:tc>
@@ -5782,7 +5857,7 @@
                       </a:r>
                     </a:p>
                   </a:txBody>
-                  <a:tcPr marL="91440" marR="91440" marT="18288" marB="18288" anchor="ctr">
+                  <a:tcPr marT="18288" marB="18288" anchor="ctr">
                     <a:solidFill>
                       <a:srgbClr val="F7F6F2"/>
                     </a:solidFill>
@@ -5805,7 +5880,7 @@
                       </a:r>
                     </a:p>
                   </a:txBody>
-                  <a:tcPr marL="91440" marR="91440" marT="18288" marB="18288" anchor="ctr">
+                  <a:tcPr marT="18288" marB="18288" anchor="ctr">
                     <a:solidFill>
                       <a:srgbClr val="F7F6F2"/>
                     </a:solidFill>
@@ -5824,16 +5899,21 @@
                           </a:solidFill>
                           <a:latin typeface="Arial"/>
                         </a:rPr>
-                        <a:t>1.3%</a:t>
+                        <a:t>1.2%</a:t>
                       </a:r>
                     </a:p>
                   </a:txBody>
-                  <a:tcPr marL="91440" marR="91440" marT="18288" marB="18288" anchor="ctr">
+                  <a:tcPr marT="18288" marB="18288" anchor="ctr">
                     <a:solidFill>
                       <a:srgbClr val="F7F6F2"/>
                     </a:solidFill>
                   </a:tcPr>
                 </a:tc>
+                <a:extLst>
+                  <a:ext uri="{0D108BD9-81ED-4DB2-BD59-A6C34878D82A}">
+                    <a16:rowId xmlns:a16="http://schemas.microsoft.com/office/drawing/2014/main" val="10006"/>
+                  </a:ext>
+                </a:extLst>
               </a:tr>
               <a:tr h="329184">
                 <a:tc>
@@ -5853,7 +5933,7 @@
                       </a:r>
                     </a:p>
                   </a:txBody>
-                  <a:tcPr marL="91440" marR="91440" marT="18288" marB="18288" anchor="ctr">
+                  <a:tcPr marT="18288" marB="18288" anchor="ctr">
                     <a:solidFill>
                       <a:srgbClr val="FFFFFF"/>
                     </a:solidFill>
@@ -5876,7 +5956,463 @@
                       </a:r>
                     </a:p>
                   </a:txBody>
-                  <a:tcPr marL="91440" marR="91440" marT="18288" marB="18288" anchor="ctr">
+                  <a:tcPr marT="18288" marB="18288" anchor="ctr">
+                    <a:solidFill>
+                      <a:srgbClr val="FFFFFF"/>
+                    </a:solidFill>
+                  </a:tcPr>
+                </a:tc>
+                <a:tc>
+                  <a:txBody>
+                    <a:bodyPr/>
+                    <a:lstStyle/>
+                    <a:p>
+                      <a:pPr algn="r"/>
+                      <a:r>
+                        <a:rPr sz="1300" b="0">
+                          <a:solidFill>
+                            <a:srgbClr val="14213D"/>
+                          </a:solidFill>
+                          <a:latin typeface="Arial"/>
+                        </a:rPr>
+                        <a:t>0.1%</a:t>
+                      </a:r>
+                    </a:p>
+                  </a:txBody>
+                  <a:tcPr marT="18288" marB="18288" anchor="ctr">
+                    <a:solidFill>
+                      <a:srgbClr val="FFFFFF"/>
+                    </a:solidFill>
+                  </a:tcPr>
+                </a:tc>
+                <a:extLst>
+                  <a:ext uri="{0D108BD9-81ED-4DB2-BD59-A6C34878D82A}">
+                    <a16:rowId xmlns:a16="http://schemas.microsoft.com/office/drawing/2014/main" val="10007"/>
+                  </a:ext>
+                </a:extLst>
+              </a:tr>
+              <a:tr h="329184">
+                <a:tc>
+                  <a:txBody>
+                    <a:bodyPr/>
+                    <a:lstStyle/>
+                    <a:p>
+                      <a:pPr algn="l"/>
+                      <a:r>
+                        <a:rPr sz="1300" b="0">
+                          <a:solidFill>
+                            <a:srgbClr val="14213D"/>
+                          </a:solidFill>
+                          <a:latin typeface="Arial"/>
+                        </a:rPr>
+                        <a:t>Events</a:t>
+                      </a:r>
+                    </a:p>
+                  </a:txBody>
+                  <a:tcPr marT="18288" marB="18288" anchor="ctr">
+                    <a:solidFill>
+                      <a:srgbClr val="F7F6F2"/>
+                    </a:solidFill>
+                  </a:tcPr>
+                </a:tc>
+                <a:tc>
+                  <a:txBody>
+                    <a:bodyPr/>
+                    <a:lstStyle/>
+                    <a:p>
+                      <a:pPr algn="r"/>
+                      <a:r>
+                        <a:rPr sz="1300" b="0">
+                          <a:solidFill>
+                            <a:srgbClr val="14213D"/>
+                          </a:solidFill>
+                          <a:latin typeface="Arial"/>
+                        </a:rPr>
+                        <a:t>$5,000</a:t>
+                      </a:r>
+                    </a:p>
+                  </a:txBody>
+                  <a:tcPr marT="18288" marB="18288" anchor="ctr">
+                    <a:solidFill>
+                      <a:srgbClr val="F7F6F2"/>
+                    </a:solidFill>
+                  </a:tcPr>
+                </a:tc>
+                <a:tc>
+                  <a:txBody>
+                    <a:bodyPr/>
+                    <a:lstStyle/>
+                    <a:p>
+                      <a:pPr algn="r"/>
+                      <a:r>
+                        <a:rPr sz="1300" b="0">
+                          <a:solidFill>
+                            <a:srgbClr val="14213D"/>
+                          </a:solidFill>
+                          <a:latin typeface="Arial"/>
+                        </a:rPr>
+                        <a:t>0.7%</a:t>
+                      </a:r>
+                    </a:p>
+                  </a:txBody>
+                  <a:tcPr marT="18288" marB="18288" anchor="ctr">
+                    <a:solidFill>
+                      <a:srgbClr val="F7F6F2"/>
+                    </a:solidFill>
+                  </a:tcPr>
+                </a:tc>
+                <a:extLst>
+                  <a:ext uri="{0D108BD9-81ED-4DB2-BD59-A6C34878D82A}">
+                    <a16:rowId xmlns:a16="http://schemas.microsoft.com/office/drawing/2014/main" val="10008"/>
+                  </a:ext>
+                </a:extLst>
+              </a:tr>
+              <a:tr h="329184">
+                <a:tc>
+                  <a:txBody>
+                    <a:bodyPr/>
+                    <a:lstStyle/>
+                    <a:p>
+                      <a:pPr algn="l"/>
+                      <a:r>
+                        <a:rPr sz="1300" b="0">
+                          <a:solidFill>
+                            <a:srgbClr val="14213D"/>
+                          </a:solidFill>
+                          <a:latin typeface="Arial"/>
+                        </a:rPr>
+                        <a:t>Truck Wraps</a:t>
+                      </a:r>
+                    </a:p>
+                  </a:txBody>
+                  <a:tcPr marT="18288" marB="18288" anchor="ctr">
+                    <a:solidFill>
+                      <a:srgbClr val="FFFFFF"/>
+                    </a:solidFill>
+                  </a:tcPr>
+                </a:tc>
+                <a:tc>
+                  <a:txBody>
+                    <a:bodyPr/>
+                    <a:lstStyle/>
+                    <a:p>
+                      <a:pPr algn="r"/>
+                      <a:r>
+                        <a:rPr sz="1300" b="0">
+                          <a:solidFill>
+                            <a:srgbClr val="14213D"/>
+                          </a:solidFill>
+                          <a:latin typeface="Arial"/>
+                        </a:rPr>
+                        <a:t>$12,500</a:t>
+                      </a:r>
+                    </a:p>
+                  </a:txBody>
+                  <a:tcPr marT="18288" marB="18288" anchor="ctr">
+                    <a:solidFill>
+                      <a:srgbClr val="FFFFFF"/>
+                    </a:solidFill>
+                  </a:tcPr>
+                </a:tc>
+                <a:tc>
+                  <a:txBody>
+                    <a:bodyPr/>
+                    <a:lstStyle/>
+                    <a:p>
+                      <a:pPr algn="r"/>
+                      <a:r>
+                        <a:rPr sz="1300" b="0">
+                          <a:solidFill>
+                            <a:srgbClr val="14213D"/>
+                          </a:solidFill>
+                          <a:latin typeface="Arial"/>
+                        </a:rPr>
+                        <a:t>1.8%</a:t>
+                      </a:r>
+                    </a:p>
+                  </a:txBody>
+                  <a:tcPr marT="18288" marB="18288" anchor="ctr">
+                    <a:solidFill>
+                      <a:srgbClr val="FFFFFF"/>
+                    </a:solidFill>
+                  </a:tcPr>
+                </a:tc>
+                <a:extLst>
+                  <a:ext uri="{0D108BD9-81ED-4DB2-BD59-A6C34878D82A}">
+                    <a16:rowId xmlns:a16="http://schemas.microsoft.com/office/drawing/2014/main" val="10009"/>
+                  </a:ext>
+                </a:extLst>
+              </a:tr>
+              <a:tr h="329184">
+                <a:tc>
+                  <a:txBody>
+                    <a:bodyPr/>
+                    <a:lstStyle/>
+                    <a:p>
+                      <a:pPr algn="l"/>
+                      <a:r>
+                        <a:rPr sz="1300" b="0">
+                          <a:solidFill>
+                            <a:srgbClr val="14213D"/>
+                          </a:solidFill>
+                          <a:latin typeface="Arial"/>
+                        </a:rPr>
+                        <a:t>Service Titan</a:t>
+                      </a:r>
+                    </a:p>
+                  </a:txBody>
+                  <a:tcPr marT="18288" marB="18288" anchor="ctr">
+                    <a:solidFill>
+                      <a:srgbClr val="F7F6F2"/>
+                    </a:solidFill>
+                  </a:tcPr>
+                </a:tc>
+                <a:tc>
+                  <a:txBody>
+                    <a:bodyPr/>
+                    <a:lstStyle/>
+                    <a:p>
+                      <a:pPr algn="r"/>
+                      <a:r>
+                        <a:rPr sz="1300" b="0">
+                          <a:solidFill>
+                            <a:srgbClr val="14213D"/>
+                          </a:solidFill>
+                          <a:latin typeface="Arial"/>
+                        </a:rPr>
+                        <a:t>$19,000</a:t>
+                      </a:r>
+                    </a:p>
+                  </a:txBody>
+                  <a:tcPr marT="18288" marB="18288" anchor="ctr">
+                    <a:solidFill>
+                      <a:srgbClr val="F7F6F2"/>
+                    </a:solidFill>
+                  </a:tcPr>
+                </a:tc>
+                <a:tc>
+                  <a:txBody>
+                    <a:bodyPr/>
+                    <a:lstStyle/>
+                    <a:p>
+                      <a:pPr algn="r"/>
+                      <a:r>
+                        <a:rPr sz="1300" b="0">
+                          <a:solidFill>
+                            <a:srgbClr val="14213D"/>
+                          </a:solidFill>
+                          <a:latin typeface="Arial"/>
+                        </a:rPr>
+                        <a:t>2.8%</a:t>
+                      </a:r>
+                    </a:p>
+                  </a:txBody>
+                  <a:tcPr marT="18288" marB="18288" anchor="ctr">
+                    <a:solidFill>
+                      <a:srgbClr val="F7F6F2"/>
+                    </a:solidFill>
+                  </a:tcPr>
+                </a:tc>
+                <a:extLst>
+                  <a:ext uri="{0D108BD9-81ED-4DB2-BD59-A6C34878D82A}">
+                    <a16:rowId xmlns:a16="http://schemas.microsoft.com/office/drawing/2014/main" val="10010"/>
+                  </a:ext>
+                </a:extLst>
+              </a:tr>
+              <a:tr h="329184">
+                <a:tc>
+                  <a:txBody>
+                    <a:bodyPr/>
+                    <a:lstStyle/>
+                    <a:p>
+                      <a:pPr algn="l"/>
+                      <a:r>
+                        <a:rPr sz="1300" b="0">
+                          <a:solidFill>
+                            <a:srgbClr val="14213D"/>
+                          </a:solidFill>
+                          <a:latin typeface="Arial"/>
+                        </a:rPr>
+                        <a:t>Contractor Commerce</a:t>
+                      </a:r>
+                    </a:p>
+                  </a:txBody>
+                  <a:tcPr marT="18288" marB="18288" anchor="ctr">
+                    <a:solidFill>
+                      <a:srgbClr val="FFFFFF"/>
+                    </a:solidFill>
+                  </a:tcPr>
+                </a:tc>
+                <a:tc>
+                  <a:txBody>
+                    <a:bodyPr/>
+                    <a:lstStyle/>
+                    <a:p>
+                      <a:pPr algn="r"/>
+                      <a:r>
+                        <a:rPr sz="1300" b="0">
+                          <a:solidFill>
+                            <a:srgbClr val="14213D"/>
+                          </a:solidFill>
+                          <a:latin typeface="Arial"/>
+                        </a:rPr>
+                        <a:t>$8,000</a:t>
+                      </a:r>
+                    </a:p>
+                  </a:txBody>
+                  <a:tcPr marT="18288" marB="18288" anchor="ctr">
+                    <a:solidFill>
+                      <a:srgbClr val="FFFFFF"/>
+                    </a:solidFill>
+                  </a:tcPr>
+                </a:tc>
+                <a:tc>
+                  <a:txBody>
+                    <a:bodyPr/>
+                    <a:lstStyle/>
+                    <a:p>
+                      <a:pPr algn="r"/>
+                      <a:r>
+                        <a:rPr sz="1300" b="0">
+                          <a:solidFill>
+                            <a:srgbClr val="14213D"/>
+                          </a:solidFill>
+                          <a:latin typeface="Arial"/>
+                        </a:rPr>
+                        <a:t>1.2%</a:t>
+                      </a:r>
+                    </a:p>
+                  </a:txBody>
+                  <a:tcPr marT="18288" marB="18288" anchor="ctr">
+                    <a:solidFill>
+                      <a:srgbClr val="FFFFFF"/>
+                    </a:solidFill>
+                  </a:tcPr>
+                </a:tc>
+                <a:extLst>
+                  <a:ext uri="{0D108BD9-81ED-4DB2-BD59-A6C34878D82A}">
+                    <a16:rowId xmlns:a16="http://schemas.microsoft.com/office/drawing/2014/main" val="10011"/>
+                  </a:ext>
+                </a:extLst>
+              </a:tr>
+              <a:tr h="329184">
+                <a:tc>
+                  <a:txBody>
+                    <a:bodyPr/>
+                    <a:lstStyle/>
+                    <a:p>
+                      <a:pPr algn="l"/>
+                      <a:r>
+                        <a:rPr sz="1300" b="0">
+                          <a:solidFill>
+                            <a:srgbClr val="14213D"/>
+                          </a:solidFill>
+                          <a:latin typeface="Arial"/>
+                        </a:rPr>
+                        <a:t>Associations</a:t>
+                      </a:r>
+                    </a:p>
+                  </a:txBody>
+                  <a:tcPr marT="18288" marB="18288" anchor="ctr">
+                    <a:solidFill>
+                      <a:srgbClr val="F7F6F2"/>
+                    </a:solidFill>
+                  </a:tcPr>
+                </a:tc>
+                <a:tc>
+                  <a:txBody>
+                    <a:bodyPr/>
+                    <a:lstStyle/>
+                    <a:p>
+                      <a:pPr algn="r"/>
+                      <a:r>
+                        <a:rPr sz="1300" b="0">
+                          <a:solidFill>
+                            <a:srgbClr val="14213D"/>
+                          </a:solidFill>
+                          <a:latin typeface="Arial"/>
+                        </a:rPr>
+                        <a:t>$750</a:t>
+                      </a:r>
+                    </a:p>
+                  </a:txBody>
+                  <a:tcPr marT="18288" marB="18288" anchor="ctr">
+                    <a:solidFill>
+                      <a:srgbClr val="F7F6F2"/>
+                    </a:solidFill>
+                  </a:tcPr>
+                </a:tc>
+                <a:tc>
+                  <a:txBody>
+                    <a:bodyPr/>
+                    <a:lstStyle/>
+                    <a:p>
+                      <a:pPr algn="r"/>
+                      <a:r>
+                        <a:rPr sz="1300" b="0">
+                          <a:solidFill>
+                            <a:srgbClr val="14213D"/>
+                          </a:solidFill>
+                          <a:latin typeface="Arial"/>
+                        </a:rPr>
+                        <a:t>0.1%</a:t>
+                      </a:r>
+                    </a:p>
+                  </a:txBody>
+                  <a:tcPr marT="18288" marB="18288" anchor="ctr">
+                    <a:solidFill>
+                      <a:srgbClr val="F7F6F2"/>
+                    </a:solidFill>
+                  </a:tcPr>
+                </a:tc>
+                <a:extLst>
+                  <a:ext uri="{0D108BD9-81ED-4DB2-BD59-A6C34878D82A}">
+                    <a16:rowId xmlns:a16="http://schemas.microsoft.com/office/drawing/2014/main" val="10012"/>
+                  </a:ext>
+                </a:extLst>
+              </a:tr>
+              <a:tr h="329184">
+                <a:tc>
+                  <a:txBody>
+                    <a:bodyPr/>
+                    <a:lstStyle/>
+                    <a:p>
+                      <a:pPr algn="l"/>
+                      <a:r>
+                        <a:rPr sz="1300" b="0">
+                          <a:solidFill>
+                            <a:srgbClr val="14213D"/>
+                          </a:solidFill>
+                          <a:latin typeface="Arial"/>
+                        </a:rPr>
+                        <a:t>Kino</a:t>
+                      </a:r>
+                    </a:p>
+                  </a:txBody>
+                  <a:tcPr marT="18288" marB="18288" anchor="ctr">
+                    <a:solidFill>
+                      <a:srgbClr val="FFFFFF"/>
+                    </a:solidFill>
+                  </a:tcPr>
+                </a:tc>
+                <a:tc>
+                  <a:txBody>
+                    <a:bodyPr/>
+                    <a:lstStyle/>
+                    <a:p>
+                      <a:pPr algn="r"/>
+                      <a:r>
+                        <a:rPr sz="1300" b="0">
+                          <a:solidFill>
+                            <a:srgbClr val="14213D"/>
+                          </a:solidFill>
+                          <a:latin typeface="Arial"/>
+                        </a:rPr>
+                        <a:t>$1,500</a:t>
+                      </a:r>
+                    </a:p>
+                  </a:txBody>
+                  <a:tcPr marT="18288" marB="18288" anchor="ctr">
                     <a:solidFill>
                       <a:srgbClr val="FFFFFF"/>
                     </a:solidFill>
@@ -5899,438 +6435,17 @@
                       </a:r>
                     </a:p>
                   </a:txBody>
-                  <a:tcPr marL="91440" marR="91440" marT="18288" marB="18288" anchor="ctr">
+                  <a:tcPr marT="18288" marB="18288" anchor="ctr">
                     <a:solidFill>
                       <a:srgbClr val="FFFFFF"/>
                     </a:solidFill>
                   </a:tcPr>
                 </a:tc>
-              </a:tr>
-              <a:tr h="329184">
-                <a:tc>
-                  <a:txBody>
-                    <a:bodyPr/>
-                    <a:lstStyle/>
-                    <a:p>
-                      <a:pPr algn="l"/>
-                      <a:r>
-                        <a:rPr sz="1300" b="0">
-                          <a:solidFill>
-                            <a:srgbClr val="14213D"/>
-                          </a:solidFill>
-                          <a:latin typeface="Arial"/>
-                        </a:rPr>
-                        <a:t>Events</a:t>
-                      </a:r>
-                    </a:p>
-                  </a:txBody>
-                  <a:tcPr marL="91440" marR="91440" marT="18288" marB="18288" anchor="ctr">
-                    <a:solidFill>
-                      <a:srgbClr val="F7F6F2"/>
-                    </a:solidFill>
-                  </a:tcPr>
-                </a:tc>
-                <a:tc>
-                  <a:txBody>
-                    <a:bodyPr/>
-                    <a:lstStyle/>
-                    <a:p>
-                      <a:pPr algn="r"/>
-                      <a:r>
-                        <a:rPr sz="1300" b="0">
-                          <a:solidFill>
-                            <a:srgbClr val="14213D"/>
-                          </a:solidFill>
-                          <a:latin typeface="Arial"/>
-                        </a:rPr>
-                        <a:t>$5,000</a:t>
-                      </a:r>
-                    </a:p>
-                  </a:txBody>
-                  <a:tcPr marL="91440" marR="91440" marT="18288" marB="18288" anchor="ctr">
-                    <a:solidFill>
-                      <a:srgbClr val="F7F6F2"/>
-                    </a:solidFill>
-                  </a:tcPr>
-                </a:tc>
-                <a:tc>
-                  <a:txBody>
-                    <a:bodyPr/>
-                    <a:lstStyle/>
-                    <a:p>
-                      <a:pPr algn="r"/>
-                      <a:r>
-                        <a:rPr sz="1300" b="0">
-                          <a:solidFill>
-                            <a:srgbClr val="14213D"/>
-                          </a:solidFill>
-                          <a:latin typeface="Arial"/>
-                        </a:rPr>
-                        <a:t>0.8%</a:t>
-                      </a:r>
-                    </a:p>
-                  </a:txBody>
-                  <a:tcPr marL="91440" marR="91440" marT="18288" marB="18288" anchor="ctr">
-                    <a:solidFill>
-                      <a:srgbClr val="F7F6F2"/>
-                    </a:solidFill>
-                  </a:tcPr>
-                </a:tc>
-              </a:tr>
-              <a:tr h="329184">
-                <a:tc>
-                  <a:txBody>
-                    <a:bodyPr/>
-                    <a:lstStyle/>
-                    <a:p>
-                      <a:pPr algn="l"/>
-                      <a:r>
-                        <a:rPr sz="1300" b="0">
-                          <a:solidFill>
-                            <a:srgbClr val="14213D"/>
-                          </a:solidFill>
-                          <a:latin typeface="Arial"/>
-                        </a:rPr>
-                        <a:t>Truck Wraps</a:t>
-                      </a:r>
-                    </a:p>
-                  </a:txBody>
-                  <a:tcPr marL="91440" marR="91440" marT="18288" marB="18288" anchor="ctr">
-                    <a:solidFill>
-                      <a:srgbClr val="FFFFFF"/>
-                    </a:solidFill>
-                  </a:tcPr>
-                </a:tc>
-                <a:tc>
-                  <a:txBody>
-                    <a:bodyPr/>
-                    <a:lstStyle/>
-                    <a:p>
-                      <a:pPr algn="r"/>
-                      <a:r>
-                        <a:rPr sz="1300" b="0">
-                          <a:solidFill>
-                            <a:srgbClr val="14213D"/>
-                          </a:solidFill>
-                          <a:latin typeface="Arial"/>
-                        </a:rPr>
-                        <a:t>$12,500</a:t>
-                      </a:r>
-                    </a:p>
-                  </a:txBody>
-                  <a:tcPr marL="91440" marR="91440" marT="18288" marB="18288" anchor="ctr">
-                    <a:solidFill>
-                      <a:srgbClr val="FFFFFF"/>
-                    </a:solidFill>
-                  </a:tcPr>
-                </a:tc>
-                <a:tc>
-                  <a:txBody>
-                    <a:bodyPr/>
-                    <a:lstStyle/>
-                    <a:p>
-                      <a:pPr algn="r"/>
-                      <a:r>
-                        <a:rPr sz="1300" b="0">
-                          <a:solidFill>
-                            <a:srgbClr val="14213D"/>
-                          </a:solidFill>
-                          <a:latin typeface="Arial"/>
-                        </a:rPr>
-                        <a:t>2.0%</a:t>
-                      </a:r>
-                    </a:p>
-                  </a:txBody>
-                  <a:tcPr marL="91440" marR="91440" marT="18288" marB="18288" anchor="ctr">
-                    <a:solidFill>
-                      <a:srgbClr val="FFFFFF"/>
-                    </a:solidFill>
-                  </a:tcPr>
-                </a:tc>
-              </a:tr>
-              <a:tr h="329184">
-                <a:tc>
-                  <a:txBody>
-                    <a:bodyPr/>
-                    <a:lstStyle/>
-                    <a:p>
-                      <a:pPr algn="l"/>
-                      <a:r>
-                        <a:rPr sz="1300" b="0">
-                          <a:solidFill>
-                            <a:srgbClr val="14213D"/>
-                          </a:solidFill>
-                          <a:latin typeface="Arial"/>
-                        </a:rPr>
-                        <a:t>Service Titan</a:t>
-                      </a:r>
-                    </a:p>
-                  </a:txBody>
-                  <a:tcPr marL="91440" marR="91440" marT="18288" marB="18288" anchor="ctr">
-                    <a:solidFill>
-                      <a:srgbClr val="F7F6F2"/>
-                    </a:solidFill>
-                  </a:tcPr>
-                </a:tc>
-                <a:tc>
-                  <a:txBody>
-                    <a:bodyPr/>
-                    <a:lstStyle/>
-                    <a:p>
-                      <a:pPr algn="r"/>
-                      <a:r>
-                        <a:rPr sz="1300" b="0">
-                          <a:solidFill>
-                            <a:srgbClr val="14213D"/>
-                          </a:solidFill>
-                          <a:latin typeface="Arial"/>
-                        </a:rPr>
-                        <a:t>$19,000</a:t>
-                      </a:r>
-                    </a:p>
-                  </a:txBody>
-                  <a:tcPr marL="91440" marR="91440" marT="18288" marB="18288" anchor="ctr">
-                    <a:solidFill>
-                      <a:srgbClr val="F7F6F2"/>
-                    </a:solidFill>
-                  </a:tcPr>
-                </a:tc>
-                <a:tc>
-                  <a:txBody>
-                    <a:bodyPr/>
-                    <a:lstStyle/>
-                    <a:p>
-                      <a:pPr algn="r"/>
-                      <a:r>
-                        <a:rPr sz="1300" b="0">
-                          <a:solidFill>
-                            <a:srgbClr val="14213D"/>
-                          </a:solidFill>
-                          <a:latin typeface="Arial"/>
-                        </a:rPr>
-                        <a:t>3.1%</a:t>
-                      </a:r>
-                    </a:p>
-                  </a:txBody>
-                  <a:tcPr marL="91440" marR="91440" marT="18288" marB="18288" anchor="ctr">
-                    <a:solidFill>
-                      <a:srgbClr val="F7F6F2"/>
-                    </a:solidFill>
-                  </a:tcPr>
-                </a:tc>
-              </a:tr>
-              <a:tr h="329184">
-                <a:tc>
-                  <a:txBody>
-                    <a:bodyPr/>
-                    <a:lstStyle/>
-                    <a:p>
-                      <a:pPr algn="l"/>
-                      <a:r>
-                        <a:rPr sz="1300" b="0">
-                          <a:solidFill>
-                            <a:srgbClr val="14213D"/>
-                          </a:solidFill>
-                          <a:latin typeface="Arial"/>
-                        </a:rPr>
-                        <a:t>Contractor Commerce</a:t>
-                      </a:r>
-                    </a:p>
-                  </a:txBody>
-                  <a:tcPr marL="91440" marR="91440" marT="18288" marB="18288" anchor="ctr">
-                    <a:solidFill>
-                      <a:srgbClr val="FFFFFF"/>
-                    </a:solidFill>
-                  </a:tcPr>
-                </a:tc>
-                <a:tc>
-                  <a:txBody>
-                    <a:bodyPr/>
-                    <a:lstStyle/>
-                    <a:p>
-                      <a:pPr algn="r"/>
-                      <a:r>
-                        <a:rPr sz="1300" b="0">
-                          <a:solidFill>
-                            <a:srgbClr val="14213D"/>
-                          </a:solidFill>
-                          <a:latin typeface="Arial"/>
-                        </a:rPr>
-                        <a:t>$8,000</a:t>
-                      </a:r>
-                    </a:p>
-                  </a:txBody>
-                  <a:tcPr marL="91440" marR="91440" marT="18288" marB="18288" anchor="ctr">
-                    <a:solidFill>
-                      <a:srgbClr val="FFFFFF"/>
-                    </a:solidFill>
-                  </a:tcPr>
-                </a:tc>
-                <a:tc>
-                  <a:txBody>
-                    <a:bodyPr/>
-                    <a:lstStyle/>
-                    <a:p>
-                      <a:pPr algn="r"/>
-                      <a:r>
-                        <a:rPr sz="1300" b="0">
-                          <a:solidFill>
-                            <a:srgbClr val="14213D"/>
-                          </a:solidFill>
-                          <a:latin typeface="Arial"/>
-                        </a:rPr>
-                        <a:t>1.3%</a:t>
-                      </a:r>
-                    </a:p>
-                  </a:txBody>
-                  <a:tcPr marL="91440" marR="91440" marT="18288" marB="18288" anchor="ctr">
-                    <a:solidFill>
-                      <a:srgbClr val="FFFFFF"/>
-                    </a:solidFill>
-                  </a:tcPr>
-                </a:tc>
-              </a:tr>
-              <a:tr h="329184">
-                <a:tc>
-                  <a:txBody>
-                    <a:bodyPr/>
-                    <a:lstStyle/>
-                    <a:p>
-                      <a:pPr algn="l"/>
-                      <a:r>
-                        <a:rPr sz="1300" b="0">
-                          <a:solidFill>
-                            <a:srgbClr val="14213D"/>
-                          </a:solidFill>
-                          <a:latin typeface="Arial"/>
-                        </a:rPr>
-                        <a:t>Associations</a:t>
-                      </a:r>
-                    </a:p>
-                  </a:txBody>
-                  <a:tcPr marL="91440" marR="91440" marT="18288" marB="18288" anchor="ctr">
-                    <a:solidFill>
-                      <a:srgbClr val="F7F6F2"/>
-                    </a:solidFill>
-                  </a:tcPr>
-                </a:tc>
-                <a:tc>
-                  <a:txBody>
-                    <a:bodyPr/>
-                    <a:lstStyle/>
-                    <a:p>
-                      <a:pPr algn="r"/>
-                      <a:r>
-                        <a:rPr sz="1300" b="0">
-                          <a:solidFill>
-                            <a:srgbClr val="14213D"/>
-                          </a:solidFill>
-                          <a:latin typeface="Arial"/>
-                        </a:rPr>
-                        <a:t>$750</a:t>
-                      </a:r>
-                    </a:p>
-                  </a:txBody>
-                  <a:tcPr marL="91440" marR="91440" marT="18288" marB="18288" anchor="ctr">
-                    <a:solidFill>
-                      <a:srgbClr val="F7F6F2"/>
-                    </a:solidFill>
-                  </a:tcPr>
-                </a:tc>
-                <a:tc>
-                  <a:txBody>
-                    <a:bodyPr/>
-                    <a:lstStyle/>
-                    <a:p>
-                      <a:pPr algn="r"/>
-                      <a:r>
-                        <a:rPr sz="1300" b="0">
-                          <a:solidFill>
-                            <a:srgbClr val="14213D"/>
-                          </a:solidFill>
-                          <a:latin typeface="Arial"/>
-                        </a:rPr>
-                        <a:t>0.1%</a:t>
-                      </a:r>
-                    </a:p>
-                  </a:txBody>
-                  <a:tcPr marL="91440" marR="91440" marT="18288" marB="18288" anchor="ctr">
-                    <a:solidFill>
-                      <a:srgbClr val="F7F6F2"/>
-                    </a:solidFill>
-                  </a:tcPr>
-                </a:tc>
-              </a:tr>
-              <a:tr h="329184">
-                <a:tc>
-                  <a:txBody>
-                    <a:bodyPr/>
-                    <a:lstStyle/>
-                    <a:p>
-                      <a:pPr algn="l"/>
-                      <a:r>
-                        <a:rPr sz="1300" b="0">
-                          <a:solidFill>
-                            <a:srgbClr val="14213D"/>
-                          </a:solidFill>
-                          <a:latin typeface="Arial"/>
-                        </a:rPr>
-                        <a:t>Kino</a:t>
-                      </a:r>
-                    </a:p>
-                  </a:txBody>
-                  <a:tcPr marL="91440" marR="91440" marT="18288" marB="18288" anchor="ctr">
-                    <a:solidFill>
-                      <a:srgbClr val="FFFFFF"/>
-                    </a:solidFill>
-                  </a:tcPr>
-                </a:tc>
-                <a:tc>
-                  <a:txBody>
-                    <a:bodyPr/>
-                    <a:lstStyle/>
-                    <a:p>
-                      <a:pPr algn="r"/>
-                      <a:r>
-                        <a:rPr sz="1300" b="0">
-                          <a:solidFill>
-                            <a:srgbClr val="14213D"/>
-                          </a:solidFill>
-                          <a:latin typeface="Arial"/>
-                        </a:rPr>
-                        <a:t>$1,500</a:t>
-                      </a:r>
-                    </a:p>
-                  </a:txBody>
-                  <a:tcPr marL="91440" marR="91440" marT="18288" marB="18288" anchor="ctr">
-                    <a:solidFill>
-                      <a:srgbClr val="FFFFFF"/>
-                    </a:solidFill>
-                  </a:tcPr>
-                </a:tc>
-                <a:tc>
-                  <a:txBody>
-                    <a:bodyPr/>
-                    <a:lstStyle/>
-                    <a:p>
-                      <a:pPr algn="r"/>
-                      <a:r>
-                        <a:rPr sz="1300" b="0">
-                          <a:solidFill>
-                            <a:srgbClr val="14213D"/>
-                          </a:solidFill>
-                          <a:latin typeface="Arial"/>
-                        </a:rPr>
-                        <a:t>0.2%</a:t>
-                      </a:r>
-                    </a:p>
-                  </a:txBody>
-                  <a:tcPr marL="91440" marR="91440" marT="18288" marB="18288" anchor="ctr">
-                    <a:solidFill>
-                      <a:srgbClr val="FFFFFF"/>
-                    </a:solidFill>
-                  </a:tcPr>
-                </a:tc>
+                <a:extLst>
+                  <a:ext uri="{0D108BD9-81ED-4DB2-BD59-A6C34878D82A}">
+                    <a16:rowId xmlns:a16="http://schemas.microsoft.com/office/drawing/2014/main" val="10013"/>
+                  </a:ext>
+                </a:extLst>
               </a:tr>
               <a:tr h="329184">
                 <a:tc>
@@ -6350,7 +6465,7 @@
                       </a:r>
                     </a:p>
                   </a:txBody>
-                  <a:tcPr marL="91440" marR="91440" marT="18288" marB="18288" anchor="ctr">
+                  <a:tcPr marT="18288" marB="18288" anchor="ctr">
                     <a:solidFill>
                       <a:srgbClr val="E8ECF3"/>
                     </a:solidFill>
@@ -6369,11 +6484,11 @@
                           </a:solidFill>
                           <a:latin typeface="Arial"/>
                         </a:rPr>
-                        <a:t>$613,750</a:t>
+                        <a:t>$679,750</a:t>
                       </a:r>
                     </a:p>
                   </a:txBody>
-                  <a:tcPr marL="91440" marR="91440" marT="18288" marB="18288" anchor="ctr">
+                  <a:tcPr marT="18288" marB="18288" anchor="ctr">
                     <a:solidFill>
                       <a:srgbClr val="E8ECF3"/>
                     </a:solidFill>
@@ -6386,7 +6501,7 @@
                     <a:p>
                       <a:pPr algn="r"/>
                       <a:r>
-                        <a:rPr sz="1300" b="1">
+                        <a:rPr sz="1300" b="1" dirty="0">
                           <a:solidFill>
                             <a:srgbClr val="14213D"/>
                           </a:solidFill>
@@ -6396,12 +6511,17 @@
                       </a:r>
                     </a:p>
                   </a:txBody>
-                  <a:tcPr marL="91440" marR="91440" marT="18288" marB="18288" anchor="ctr">
+                  <a:tcPr marT="18288" marB="18288" anchor="ctr">
                     <a:solidFill>
                       <a:srgbClr val="E8ECF3"/>
                     </a:solidFill>
                   </a:tcPr>
                 </a:tc>
+                <a:extLst>
+                  <a:ext uri="{0D108BD9-81ED-4DB2-BD59-A6C34878D82A}">
+                    <a16:rowId xmlns:a16="http://schemas.microsoft.com/office/drawing/2014/main" val="10014"/>
+                  </a:ext>
+                </a:extLst>
               </a:tr>
             </a:tbl>
           </a:graphicData>
@@ -6452,6 +6572,7 @@
           <a:lstStyle/>
           <a:p>
             <a:pPr algn="ctr"/>
+            <a:endParaRPr/>
           </a:p>
         </p:txBody>
       </p:sp>
@@ -6472,7 +6593,7 @@
           <a:noFill/>
         </p:spPr>
         <p:txBody>
-          <a:bodyPr wrap="square" anchor="t" lIns="0" rIns="0" tIns="0" bIns="0">
+          <a:bodyPr wrap="square" lIns="0" tIns="0" rIns="0" bIns="0" anchor="t">
             <a:spAutoFit/>
           </a:bodyPr>
           <a:lstStyle/>
@@ -6507,7 +6628,7 @@
           <a:noFill/>
         </p:spPr>
         <p:txBody>
-          <a:bodyPr wrap="square" anchor="t" lIns="0" rIns="0" tIns="0" bIns="0">
+          <a:bodyPr wrap="square" lIns="0" tIns="0" rIns="0" bIns="0" anchor="t">
             <a:spAutoFit/>
           </a:bodyPr>
           <a:lstStyle/>
@@ -6520,196 +6641,7 @@
                 </a:solidFill>
                 <a:latin typeface="Arial"/>
               </a:rPr>
-              <a:t>$613,750</a:t>
-            </a:r>
-          </a:p>
-        </p:txBody>
-      </p:sp>
-      <p:sp>
-        <p:nvSpPr>
-          <p:cNvPr id="9" name="TextBox 8"/>
-          <p:cNvSpPr txBox="1"/>
-          <p:nvPr/>
-        </p:nvSpPr>
-        <p:spPr>
-          <a:xfrm>
-            <a:off x="7909560" y="2788920"/>
-            <a:ext cx="3413455" cy="365760"/>
-          </a:xfrm>
-          <a:prstGeom prst="rect">
-            <a:avLst/>
-          </a:prstGeom>
-          <a:noFill/>
-        </p:spPr>
-        <p:txBody>
-          <a:bodyPr wrap="square" anchor="t" lIns="0" rIns="0" tIns="0" bIns="0">
-            <a:spAutoFit/>
-          </a:bodyPr>
-          <a:lstStyle/>
-          <a:p>
-            <a:pPr algn="l"/>
-            <a:r>
-              <a:rPr sz="1400" b="0">
-                <a:solidFill>
-                  <a:srgbClr val="C9D3E3"/>
-                </a:solidFill>
-                <a:latin typeface="Arial"/>
-              </a:rPr>
-              <a:t>13 line items</a:t>
-            </a:r>
-          </a:p>
-        </p:txBody>
-      </p:sp>
-      <p:sp>
-        <p:nvSpPr>
-          <p:cNvPr id="10" name="Largest items"/>
-          <p:cNvSpPr/>
-          <p:nvPr/>
-        </p:nvSpPr>
-        <p:spPr>
-          <a:xfrm>
-            <a:off x="7589520" y="3703320"/>
-            <a:ext cx="4053535" cy="2468880"/>
-          </a:xfrm>
-          <a:prstGeom prst="roundRect">
-            <a:avLst>
-              <a:gd name="adj" fmla="val 5000"/>
-            </a:avLst>
-          </a:prstGeom>
-          <a:solidFill>
-            <a:srgbClr val="FFFFFF"/>
-          </a:solidFill>
-          <a:ln w="9525">
-            <a:solidFill>
-              <a:srgbClr val="E2E0D8"/>
-            </a:solidFill>
-          </a:ln>
-          <a:effectLst/>
-        </p:spPr>
-        <p:style>
-          <a:lnRef idx="1">
-            <a:schemeClr val="accent1"/>
-          </a:lnRef>
-          <a:fillRef idx="3">
-            <a:schemeClr val="accent1"/>
-          </a:fillRef>
-          <a:effectRef idx="2">
-            <a:schemeClr val="accent1"/>
-          </a:effectRef>
-          <a:fontRef idx="minor">
-            <a:schemeClr val="lt1"/>
-          </a:fontRef>
-        </p:style>
-        <p:txBody>
-          <a:bodyPr rtlCol="0" anchor="ctr"/>
-          <a:lstStyle/>
-          <a:p>
-            <a:pPr algn="ctr"/>
-          </a:p>
-        </p:txBody>
-      </p:sp>
-      <p:sp>
-        <p:nvSpPr>
-          <p:cNvPr id="11" name="TextBox 10"/>
-          <p:cNvSpPr txBox="1"/>
-          <p:nvPr/>
-        </p:nvSpPr>
-        <p:spPr>
-          <a:xfrm>
-            <a:off x="7909560" y="3977639"/>
-            <a:ext cx="3413455" cy="274320"/>
-          </a:xfrm>
-          <a:prstGeom prst="rect">
-            <a:avLst/>
-          </a:prstGeom>
-          <a:noFill/>
-        </p:spPr>
-        <p:txBody>
-          <a:bodyPr wrap="square" anchor="t" lIns="0" rIns="0" tIns="0" bIns="0">
-            <a:spAutoFit/>
-          </a:bodyPr>
-          <a:lstStyle/>
-          <a:p>
-            <a:pPr algn="l"/>
-            <a:r>
-              <a:rPr sz="1200" b="1">
-                <a:solidFill>
-                  <a:srgbClr val="5A6478"/>
-                </a:solidFill>
-                <a:latin typeface="Arial"/>
-              </a:rPr>
-              <a:t>LARGEST ITEMS</a:t>
-            </a:r>
-          </a:p>
-        </p:txBody>
-      </p:sp>
-      <p:sp>
-        <p:nvSpPr>
-          <p:cNvPr id="12" name="TextBox 11"/>
-          <p:cNvSpPr txBox="1"/>
-          <p:nvPr/>
-        </p:nvSpPr>
-        <p:spPr>
-          <a:xfrm>
-            <a:off x="7909560" y="4389120"/>
-            <a:ext cx="3413455" cy="1463040"/>
-          </a:xfrm>
-          <a:prstGeom prst="rect">
-            <a:avLst/>
-          </a:prstGeom>
-          <a:noFill/>
-        </p:spPr>
-        <p:txBody>
-          <a:bodyPr wrap="square" anchor="t" lIns="0" rIns="0" tIns="0" bIns="0">
-            <a:spAutoFit/>
-          </a:bodyPr>
-          <a:lstStyle/>
-          <a:p>
-            <a:pPr algn="l">
-              <a:spcAft>
-                <a:spcPts val="800"/>
-              </a:spcAft>
-            </a:pPr>
-            <a:r>
-              <a:rPr sz="1600" b="0">
-                <a:solidFill>
-                  <a:srgbClr val="14213D"/>
-                </a:solidFill>
-                <a:latin typeface="Arial"/>
-              </a:rPr>
-              <a:t>Direct Response/Digital: 68%</a:t>
-            </a:r>
-          </a:p>
-          <a:p>
-            <a:pPr algn="l">
-              <a:spcAft>
-                <a:spcPts val="800"/>
-              </a:spcAft>
-            </a:pPr>
-            <a:r>
-              <a:rPr sz="1600" b="0">
-                <a:solidFill>
-                  <a:srgbClr val="14213D"/>
-                </a:solidFill>
-                <a:latin typeface="Arial"/>
-              </a:rPr>
-              <a:t>Direct Mail: 12%</a:t>
-            </a:r>
-          </a:p>
-          <a:p>
-            <a:pPr algn="l">
-              <a:spcAft>
-                <a:spcPts val="800"/>
-              </a:spcAft>
-            </a:pPr>
-            <a:r>
-              <a:rPr sz="1600" b="0">
-                <a:solidFill>
-                  <a:srgbClr val="14213D"/>
-                </a:solidFill>
-                <a:latin typeface="Arial"/>
-              </a:rPr>
-              <a:t>SEO and Aespire: 5% each</a:t>
+              <a:t>$679,750</a:t>
             </a:r>
           </a:p>
         </p:txBody>

</xml_diff>

<commit_message>
Retotal 2027 marketing budget to $667,750
Co-Authored-By: Claude Opus 5.5 <noreply@anthropic.com>
Claude-Session: https://claude.ai/code/session_015KGeERGX8tZXyoMsdSGKK4
</commit_message>
<xml_diff>
--- a/2027_Marketing_Plan.pptx
+++ b/2027_Marketing_Plan.pptx
@@ -5281,7 +5281,7 @@
                 </a:solidFill>
                 <a:latin typeface="Arial"/>
               </a:rPr>
-              <a:t>Marketing Budget: $679,750</a:t>
+              <a:t>Marketing Budget: $667,750</a:t>
             </a:r>
           </a:p>
         </p:txBody>
@@ -5330,7 +5330,7 @@
           <p:nvPr>
             <p:extLst>
               <p:ext uri="{D42A27DB-BD31-4B8C-83A1-F6EECF244321}">
-                <p14:modId xmlns:p14="http://schemas.microsoft.com/office/powerpoint/2010/main" val="816310501"/>
+                <p14:modId xmlns:p14="http://schemas.microsoft.com/office/powerpoint/2010/main" val="1511428862"/>
               </p:ext>
             </p:extLst>
           </p:nvPr>
@@ -5481,16 +5481,7 @@
                           </a:solidFill>
                           <a:latin typeface="Arial"/>
                         </a:rPr>
-                        <a:t>$4</a:t>
-                      </a:r>
-                      <a:r>
-                        <a:rPr lang="en-US" sz="1300" b="0" dirty="0">
-                          <a:solidFill>
-                            <a:srgbClr val="14213D"/>
-                          </a:solidFill>
-                          <a:latin typeface="Arial"/>
-                        </a:rPr>
-                        <a:t>86,000</a:t>
+                        <a:t>$474,000</a:t>
                       </a:r>
                       <a:endParaRPr sz="1300" b="0" dirty="0">
                         <a:solidFill>
@@ -5519,7 +5510,7 @@
                           </a:solidFill>
                           <a:latin typeface="Arial"/>
                         </a:rPr>
-                        <a:t>71.5%</a:t>
+                        <a:t>71.0%</a:t>
                       </a:r>
                     </a:p>
                   </a:txBody>
@@ -5595,7 +5586,7 @@
                           </a:solidFill>
                           <a:latin typeface="Arial"/>
                         </a:rPr>
-                        <a:t>4.4%</a:t>
+                        <a:t>4.5%</a:t>
                       </a:r>
                     </a:p>
                   </a:txBody>
@@ -5671,7 +5662,7 @@
                           </a:solidFill>
                           <a:latin typeface="Arial"/>
                         </a:rPr>
-                        <a:t>4.4%</a:t>
+                        <a:t>4.5%</a:t>
                       </a:r>
                     </a:p>
                   </a:txBody>
@@ -5747,7 +5738,7 @@
                           </a:solidFill>
                           <a:latin typeface="Arial"/>
                         </a:rPr>
-                        <a:t>11.0%</a:t>
+                        <a:t>11.2%</a:t>
                       </a:r>
                     </a:p>
                   </a:txBody>
@@ -6127,7 +6118,7 @@
                           </a:solidFill>
                           <a:latin typeface="Arial"/>
                         </a:rPr>
-                        <a:t>1.8%</a:t>
+                        <a:t>1.9%</a:t>
                       </a:r>
                     </a:p>
                   </a:txBody>
@@ -6484,7 +6475,7 @@
                           </a:solidFill>
                           <a:latin typeface="Arial"/>
                         </a:rPr>
-                        <a:t>$679,750</a:t>
+                        <a:t>$667,750</a:t>
                       </a:r>
                     </a:p>
                   </a:txBody>
@@ -6641,7 +6632,7 @@
                 </a:solidFill>
                 <a:latin typeface="Arial"/>
               </a:rPr>
-              <a:t>$679,750</a:t>
+              <a:t>$667,750</a:t>
             </a:r>
           </a:p>
         </p:txBody>

</xml_diff>